<commit_message>
Livrables : présentations (prospection, investisseur) + specs mis à jour
- Prospection & Investisseur : nouvelle slide « Grands comptes / groupes
  multi-BU » (prévisionnel 12 mois, marge consolidée BU/Practice, hiérarchie
  6 niveaux, recrutement intelligent + localisation/mobilité, sécurité RGPD
  auditée, robustesse). PPTX + PDF régénérés.
- Spécifications : nouvelle section 13 « Évolutions récentes » (durcissement
  sécurité/RGPD + audit log, pilotage/prévisionnel, multi-BU, recrutement
  pipeline partagé + matching + localisation classifiée + mobilité régionale,
  qualité/tests). DOCX + PDF régénérés.

Co-Authored-By: Claude Opus 4.8 <noreply@anthropic.com>
Claude-Session: https://claude.ai/code/session_01USvXvdfgNeVsVaFCtcwkou
</commit_message>
<xml_diff>
--- a/deliverables/Konsilys_Presentation_Prospection.pptx
+++ b/deliverables/Konsilys_Presentation_Prospection.pptx
@@ -14,6 +14,7 @@
     <p:sldId id="262" r:id="rId13"/>
     <p:sldId id="263" r:id="rId14"/>
     <p:sldId id="264" r:id="rId15"/>
+    <p:sldId id="265" r:id="rId16"/>
   </p:sldIdLst>
   <p:sldSz cx="12191695" cy="6858000" type="screen4x3"/>
   <p:notesSz cx="6858000" cy="9144000"/>
@@ -3574,6 +3575,478 @@
 </p:sld>
 </file>
 
+<file path=ppt/slides/slide10.xml><?xml version="1.0" encoding="utf-8"?>
+<p:sld xmlns:a="http://schemas.openxmlformats.org/drawingml/2006/main" xmlns:p="http://schemas.openxmlformats.org/presentationml/2006/main" xmlns:r="http://schemas.openxmlformats.org/officeDocument/2006/relationships">
+  <p:cSld>
+    <p:spTree>
+      <p:nvGrpSpPr>
+        <p:cNvPr id="1" name=""/>
+        <p:cNvGrpSpPr/>
+        <p:nvPr/>
+      </p:nvGrpSpPr>
+      <p:grpSpPr/>
+      <p:sp>
+        <p:nvSpPr>
+          <p:cNvPr id="2" name="Rectangle 1"/>
+          <p:cNvSpPr/>
+          <p:nvPr/>
+        </p:nvSpPr>
+        <p:spPr>
+          <a:xfrm>
+            <a:off x="0" y="0"/>
+            <a:ext cx="12191695" cy="6858000"/>
+          </a:xfrm>
+          <a:prstGeom prst="rect">
+            <a:avLst/>
+          </a:prstGeom>
+          <a:solidFill>
+            <a:srgbClr val="1B2B3A"/>
+          </a:solidFill>
+          <a:ln>
+            <a:noFill/>
+          </a:ln>
+          <a:effectLst/>
+        </p:spPr>
+        <p:style>
+          <a:lnRef idx="1">
+            <a:schemeClr val="accent1"/>
+          </a:lnRef>
+          <a:fillRef idx="3">
+            <a:schemeClr val="accent1"/>
+          </a:fillRef>
+          <a:effectRef idx="2">
+            <a:schemeClr val="accent1"/>
+          </a:effectRef>
+          <a:fontRef idx="minor">
+            <a:schemeClr val="lt1"/>
+          </a:fontRef>
+        </p:style>
+        <p:txBody>
+          <a:bodyPr rtlCol="0" anchor="ctr"/>
+          <a:lstStyle/>
+          <a:p>
+            <a:pPr algn="ctr"/>
+          </a:p>
+        </p:txBody>
+      </p:sp>
+      <p:sp>
+        <p:nvSpPr>
+          <p:cNvPr id="3" name="Rectangle 2"/>
+          <p:cNvSpPr/>
+          <p:nvPr/>
+        </p:nvSpPr>
+        <p:spPr>
+          <a:xfrm>
+            <a:off x="0" y="0"/>
+            <a:ext cx="12191695" cy="6858000"/>
+          </a:xfrm>
+          <a:prstGeom prst="rect">
+            <a:avLst/>
+          </a:prstGeom>
+          <a:solidFill>
+            <a:srgbClr val="1B2B3A"/>
+          </a:solidFill>
+          <a:ln>
+            <a:noFill/>
+          </a:ln>
+          <a:effectLst/>
+        </p:spPr>
+        <p:style>
+          <a:lnRef idx="1">
+            <a:schemeClr val="accent1"/>
+          </a:lnRef>
+          <a:fillRef idx="3">
+            <a:schemeClr val="accent1"/>
+          </a:fillRef>
+          <a:effectRef idx="2">
+            <a:schemeClr val="accent1"/>
+          </a:effectRef>
+          <a:fontRef idx="minor">
+            <a:schemeClr val="lt1"/>
+          </a:fontRef>
+        </p:style>
+        <p:txBody>
+          <a:bodyPr rtlCol="0" anchor="ctr"/>
+          <a:lstStyle/>
+          <a:p>
+            <a:pPr algn="ctr"/>
+          </a:p>
+        </p:txBody>
+      </p:sp>
+      <p:sp>
+        <p:nvSpPr>
+          <p:cNvPr id="4" name="Rectangle 3"/>
+          <p:cNvSpPr/>
+          <p:nvPr/>
+        </p:nvSpPr>
+        <p:spPr>
+          <a:xfrm>
+            <a:off x="0" y="0"/>
+            <a:ext cx="256032" cy="6858000"/>
+          </a:xfrm>
+          <a:prstGeom prst="rect">
+            <a:avLst/>
+          </a:prstGeom>
+          <a:solidFill>
+            <a:srgbClr val="84CC16"/>
+          </a:solidFill>
+          <a:ln>
+            <a:noFill/>
+          </a:ln>
+          <a:effectLst/>
+        </p:spPr>
+        <p:style>
+          <a:lnRef idx="1">
+            <a:schemeClr val="accent1"/>
+          </a:lnRef>
+          <a:fillRef idx="3">
+            <a:schemeClr val="accent1"/>
+          </a:fillRef>
+          <a:effectRef idx="2">
+            <a:schemeClr val="accent1"/>
+          </a:effectRef>
+          <a:fontRef idx="minor">
+            <a:schemeClr val="lt1"/>
+          </a:fontRef>
+        </p:style>
+        <p:txBody>
+          <a:bodyPr rtlCol="0" anchor="ctr"/>
+          <a:lstStyle/>
+          <a:p>
+            <a:pPr algn="ctr"/>
+          </a:p>
+        </p:txBody>
+      </p:sp>
+      <p:sp>
+        <p:nvSpPr>
+          <p:cNvPr id="5" name="Rectangle 4"/>
+          <p:cNvSpPr/>
+          <p:nvPr/>
+        </p:nvSpPr>
+        <p:spPr>
+          <a:xfrm>
+            <a:off x="914400" y="987552"/>
+            <a:ext cx="82296" cy="146304"/>
+          </a:xfrm>
+          <a:prstGeom prst="rect">
+            <a:avLst/>
+          </a:prstGeom>
+          <a:solidFill>
+            <a:srgbClr val="FFFFFF"/>
+          </a:solidFill>
+          <a:ln>
+            <a:noFill/>
+          </a:ln>
+          <a:effectLst/>
+        </p:spPr>
+        <p:style>
+          <a:lnRef idx="1">
+            <a:schemeClr val="accent1"/>
+          </a:lnRef>
+          <a:fillRef idx="3">
+            <a:schemeClr val="accent1"/>
+          </a:fillRef>
+          <a:effectRef idx="2">
+            <a:schemeClr val="accent1"/>
+          </a:effectRef>
+          <a:fontRef idx="minor">
+            <a:schemeClr val="lt1"/>
+          </a:fontRef>
+        </p:style>
+        <p:txBody>
+          <a:bodyPr rtlCol="0" anchor="ctr"/>
+          <a:lstStyle/>
+          <a:p>
+            <a:pPr algn="ctr"/>
+          </a:p>
+        </p:txBody>
+      </p:sp>
+      <p:sp>
+        <p:nvSpPr>
+          <p:cNvPr id="6" name="Rectangle 5"/>
+          <p:cNvSpPr/>
+          <p:nvPr/>
+        </p:nvSpPr>
+        <p:spPr>
+          <a:xfrm>
+            <a:off x="1033271" y="914400"/>
+            <a:ext cx="82296" cy="219456"/>
+          </a:xfrm>
+          <a:prstGeom prst="rect">
+            <a:avLst/>
+          </a:prstGeom>
+          <a:solidFill>
+            <a:srgbClr val="FFFFFF"/>
+          </a:solidFill>
+          <a:ln>
+            <a:noFill/>
+          </a:ln>
+          <a:effectLst/>
+        </p:spPr>
+        <p:style>
+          <a:lnRef idx="1">
+            <a:schemeClr val="accent1"/>
+          </a:lnRef>
+          <a:fillRef idx="3">
+            <a:schemeClr val="accent1"/>
+          </a:fillRef>
+          <a:effectRef idx="2">
+            <a:schemeClr val="accent1"/>
+          </a:effectRef>
+          <a:fontRef idx="minor">
+            <a:schemeClr val="lt1"/>
+          </a:fontRef>
+        </p:style>
+        <p:txBody>
+          <a:bodyPr rtlCol="0" anchor="ctr"/>
+          <a:lstStyle/>
+          <a:p>
+            <a:pPr algn="ctr"/>
+          </a:p>
+        </p:txBody>
+      </p:sp>
+      <p:sp>
+        <p:nvSpPr>
+          <p:cNvPr id="7" name="Rectangle 6"/>
+          <p:cNvSpPr/>
+          <p:nvPr/>
+        </p:nvSpPr>
+        <p:spPr>
+          <a:xfrm>
+            <a:off x="1152143" y="822959"/>
+            <a:ext cx="82296" cy="310896"/>
+          </a:xfrm>
+          <a:prstGeom prst="rect">
+            <a:avLst/>
+          </a:prstGeom>
+          <a:solidFill>
+            <a:srgbClr val="84CC16"/>
+          </a:solidFill>
+          <a:ln>
+            <a:noFill/>
+          </a:ln>
+          <a:effectLst/>
+        </p:spPr>
+        <p:style>
+          <a:lnRef idx="1">
+            <a:schemeClr val="accent1"/>
+          </a:lnRef>
+          <a:fillRef idx="3">
+            <a:schemeClr val="accent1"/>
+          </a:fillRef>
+          <a:effectRef idx="2">
+            <a:schemeClr val="accent1"/>
+          </a:effectRef>
+          <a:fontRef idx="minor">
+            <a:schemeClr val="lt1"/>
+          </a:fontRef>
+        </p:style>
+        <p:txBody>
+          <a:bodyPr rtlCol="0" anchor="ctr"/>
+          <a:lstStyle/>
+          <a:p>
+            <a:pPr algn="ctr"/>
+          </a:p>
+        </p:txBody>
+      </p:sp>
+      <p:sp>
+        <p:nvSpPr>
+          <p:cNvPr id="8" name="TextBox 7"/>
+          <p:cNvSpPr txBox="1"/>
+          <p:nvPr/>
+        </p:nvSpPr>
+        <p:spPr>
+          <a:xfrm>
+            <a:off x="1371600" y="768096"/>
+            <a:ext cx="2743200" cy="457200"/>
+          </a:xfrm>
+          <a:prstGeom prst="rect">
+            <a:avLst/>
+          </a:prstGeom>
+          <a:noFill/>
+        </p:spPr>
+        <p:txBody>
+          <a:bodyPr wrap="square">
+            <a:spAutoFit/>
+          </a:bodyPr>
+          <a:lstStyle/>
+          <a:p>
+            <a:pPr algn="l">
+              <a:spcAft>
+                <a:spcPts val="600"/>
+              </a:spcAft>
+            </a:pPr>
+            <a:r>
+              <a:rPr sz="2000" b="1" i="0">
+                <a:solidFill>
+                  <a:srgbClr val="FFFFFF"/>
+                </a:solidFill>
+                <a:latin typeface="Calibri"/>
+              </a:rPr>
+              <a:t>Konsilys</a:t>
+            </a:r>
+          </a:p>
+        </p:txBody>
+      </p:sp>
+      <p:sp>
+        <p:nvSpPr>
+          <p:cNvPr id="9" name="TextBox 8"/>
+          <p:cNvSpPr txBox="1"/>
+          <p:nvPr/>
+        </p:nvSpPr>
+        <p:spPr>
+          <a:xfrm>
+            <a:off x="868680" y="2377440"/>
+            <a:ext cx="10424160" cy="1828800"/>
+          </a:xfrm>
+          <a:prstGeom prst="rect">
+            <a:avLst/>
+          </a:prstGeom>
+          <a:noFill/>
+        </p:spPr>
+        <p:txBody>
+          <a:bodyPr wrap="square">
+            <a:spAutoFit/>
+          </a:bodyPr>
+          <a:lstStyle/>
+          <a:p>
+            <a:pPr algn="l">
+              <a:spcAft>
+                <a:spcPts val="1000"/>
+              </a:spcAft>
+            </a:pPr>
+            <a:r>
+              <a:rPr sz="3800" b="1" i="0">
+                <a:solidFill>
+                  <a:srgbClr val="FFFFFF"/>
+                </a:solidFill>
+                <a:latin typeface="Calibri"/>
+              </a:rPr>
+              <a:t>Prêt à piloter votre ESN autrement ?</a:t>
+            </a:r>
+          </a:p>
+          <a:p>
+            <a:pPr algn="l">
+              <a:spcAft>
+                <a:spcPts val="600"/>
+              </a:spcAft>
+            </a:pPr>
+            <a:r>
+              <a:rPr sz="1800" b="0" i="0">
+                <a:solidFill>
+                  <a:srgbClr val="C7D2DD"/>
+                </a:solidFill>
+                <a:latin typeface="Calibri"/>
+              </a:rPr>
+              <a:t>Souscrivez en ligne dès aujourd'hui, ou demandez une démonstration personnalisée avec vos propres données.</a:t>
+            </a:r>
+          </a:p>
+        </p:txBody>
+      </p:sp>
+      <p:sp>
+        <p:nvSpPr>
+          <p:cNvPr id="10" name="Rounded Rectangle 9"/>
+          <p:cNvSpPr/>
+          <p:nvPr/>
+        </p:nvSpPr>
+        <p:spPr>
+          <a:xfrm>
+            <a:off x="868680" y="4480560"/>
+            <a:ext cx="3017520" cy="777240"/>
+          </a:xfrm>
+          <a:prstGeom prst="roundRect">
+            <a:avLst/>
+          </a:prstGeom>
+          <a:solidFill>
+            <a:srgbClr val="84CC16"/>
+          </a:solidFill>
+          <a:ln>
+            <a:noFill/>
+          </a:ln>
+          <a:effectLst/>
+        </p:spPr>
+        <p:style>
+          <a:lnRef idx="1">
+            <a:schemeClr val="accent1"/>
+          </a:lnRef>
+          <a:fillRef idx="3">
+            <a:schemeClr val="accent1"/>
+          </a:fillRef>
+          <a:effectRef idx="2">
+            <a:schemeClr val="accent1"/>
+          </a:effectRef>
+          <a:fontRef idx="minor">
+            <a:schemeClr val="lt1"/>
+          </a:fontRef>
+        </p:style>
+        <p:txBody>
+          <a:bodyPr rtlCol="0" anchor="ctr"/>
+          <a:lstStyle/>
+          <a:p>
+            <a:pPr algn="ctr">
+              <a:spcAft>
+                <a:spcPts val="600"/>
+              </a:spcAft>
+            </a:pPr>
+            <a:r>
+              <a:rPr sz="1800" b="1" i="0">
+                <a:solidFill>
+                  <a:srgbClr val="1B2B3A"/>
+                </a:solidFill>
+                <a:latin typeface="Calibri"/>
+              </a:rPr>
+              <a:t>konsilys.fr</a:t>
+            </a:r>
+          </a:p>
+        </p:txBody>
+      </p:sp>
+      <p:sp>
+        <p:nvSpPr>
+          <p:cNvPr id="11" name="TextBox 10"/>
+          <p:cNvSpPr txBox="1"/>
+          <p:nvPr/>
+        </p:nvSpPr>
+        <p:spPr>
+          <a:xfrm>
+            <a:off x="4206240" y="4617720"/>
+            <a:ext cx="6400800" cy="640080"/>
+          </a:xfrm>
+          <a:prstGeom prst="rect">
+            <a:avLst/>
+          </a:prstGeom>
+          <a:noFill/>
+        </p:spPr>
+        <p:txBody>
+          <a:bodyPr wrap="square">
+            <a:spAutoFit/>
+          </a:bodyPr>
+          <a:lstStyle/>
+          <a:p>
+            <a:pPr algn="l">
+              <a:spcAft>
+                <a:spcPts val="600"/>
+              </a:spcAft>
+            </a:pPr>
+            <a:r>
+              <a:rPr sz="1800" b="1" i="0">
+                <a:solidFill>
+                  <a:srgbClr val="FFFFFF"/>
+                </a:solidFill>
+                <a:latin typeface="Calibri"/>
+              </a:rPr>
+              <a:t>contact@konsilys.fr</a:t>
+            </a:r>
+          </a:p>
+        </p:txBody>
+      </p:sp>
+    </p:spTree>
+  </p:cSld>
+  <p:clrMapOvr>
+    <a:masterClrMapping/>
+  </p:clrMapOvr>
+</p:sld>
+</file>
+
 <file path=ppt/slides/slide2.xml><?xml version="1.0" encoding="utf-8"?>
 <p:sld xmlns:a="http://schemas.openxmlformats.org/drawingml/2006/main" xmlns:p="http://schemas.openxmlformats.org/presentationml/2006/main" xmlns:r="http://schemas.openxmlformats.org/officeDocument/2006/relationships">
   <p:cSld>
@@ -8750,7 +9223,7 @@
             <a:avLst/>
           </a:prstGeom>
           <a:solidFill>
-            <a:srgbClr val="1B2B3A"/>
+            <a:srgbClr val="FFFFFF"/>
           </a:solidFill>
           <a:ln>
             <a:noFill/>
@@ -8781,16 +9254,16 @@
       </p:sp>
       <p:sp>
         <p:nvSpPr>
-          <p:cNvPr id="3" name="Rectangle 2"/>
+          <p:cNvPr id="3" name="Rounded Rectangle 2"/>
           <p:cNvSpPr/>
           <p:nvPr/>
         </p:nvSpPr>
         <p:spPr>
           <a:xfrm>
-            <a:off x="0" y="0"/>
-            <a:ext cx="12191695" cy="6858000"/>
-          </a:xfrm>
-          <a:prstGeom prst="rect">
+            <a:off x="822960" y="594360"/>
+            <a:ext cx="2560320" cy="384048"/>
+          </a:xfrm>
+          <a:prstGeom prst="roundRect">
             <a:avLst/>
           </a:prstGeom>
           <a:solidFill>
@@ -8816,6 +9289,104 @@
           </a:fontRef>
         </p:style>
         <p:txBody>
+          <a:bodyPr rtlCol="0" anchor="ctr" wrap="square" tIns="25400" bIns="25400"/>
+          <a:lstStyle/>
+          <a:p>
+            <a:pPr algn="ctr">
+              <a:spcAft>
+                <a:spcPts val="600"/>
+              </a:spcAft>
+            </a:pPr>
+            <a:r>
+              <a:rPr sz="1100" b="1" i="0">
+                <a:solidFill>
+                  <a:srgbClr val="FFFFFF"/>
+                </a:solidFill>
+                <a:latin typeface="Calibri"/>
+              </a:rPr>
+              <a:t>GRANDS COMPTES</a:t>
+            </a:r>
+          </a:p>
+        </p:txBody>
+      </p:sp>
+      <p:sp>
+        <p:nvSpPr>
+          <p:cNvPr id="4" name="TextBox 3"/>
+          <p:cNvSpPr txBox="1"/>
+          <p:nvPr/>
+        </p:nvSpPr>
+        <p:spPr>
+          <a:xfrm>
+            <a:off x="822960" y="1005840"/>
+            <a:ext cx="10515600" cy="822960"/>
+          </a:xfrm>
+          <a:prstGeom prst="rect">
+            <a:avLst/>
+          </a:prstGeom>
+          <a:noFill/>
+        </p:spPr>
+        <p:txBody>
+          <a:bodyPr wrap="square">
+            <a:spAutoFit/>
+          </a:bodyPr>
+          <a:lstStyle/>
+          <a:p>
+            <a:pPr algn="l">
+              <a:spcAft>
+                <a:spcPts val="600"/>
+              </a:spcAft>
+            </a:pPr>
+            <a:r>
+              <a:rPr sz="3000" b="1" i="0">
+                <a:solidFill>
+                  <a:srgbClr val="1B2B3A"/>
+                </a:solidFill>
+                <a:latin typeface="Calibri"/>
+              </a:rPr>
+              <a:t>Conçu pour les groupes multi-BU</a:t>
+            </a:r>
+          </a:p>
+        </p:txBody>
+      </p:sp>
+      <p:sp>
+        <p:nvSpPr>
+          <p:cNvPr id="5" name="Rounded Rectangle 4"/>
+          <p:cNvSpPr/>
+          <p:nvPr/>
+        </p:nvSpPr>
+        <p:spPr>
+          <a:xfrm>
+            <a:off x="822960" y="1965960"/>
+            <a:ext cx="3429000" cy="2103120"/>
+          </a:xfrm>
+          <a:prstGeom prst="roundRect">
+            <a:avLst/>
+          </a:prstGeom>
+          <a:solidFill>
+            <a:srgbClr val="F7F9FB"/>
+          </a:solidFill>
+          <a:ln w="12700">
+            <a:solidFill>
+              <a:srgbClr val="E2E8F0"/>
+            </a:solidFill>
+          </a:ln>
+          <a:effectLst/>
+        </p:spPr>
+        <p:style>
+          <a:lnRef idx="1">
+            <a:schemeClr val="accent1"/>
+          </a:lnRef>
+          <a:fillRef idx="3">
+            <a:schemeClr val="accent1"/>
+          </a:fillRef>
+          <a:effectRef idx="2">
+            <a:schemeClr val="accent1"/>
+          </a:effectRef>
+          <a:fontRef idx="minor">
+            <a:schemeClr val="lt1"/>
+          </a:fontRef>
+        </p:style>
+        <p:txBody>
           <a:bodyPr rtlCol="0" anchor="ctr"/>
           <a:lstStyle/>
           <a:p>
@@ -8825,14 +9396,14 @@
       </p:sp>
       <p:sp>
         <p:nvSpPr>
-          <p:cNvPr id="4" name="Rectangle 3"/>
+          <p:cNvPr id="6" name="Rectangle 5"/>
           <p:cNvSpPr/>
           <p:nvPr/>
         </p:nvSpPr>
         <p:spPr>
           <a:xfrm>
-            <a:off x="0" y="0"/>
-            <a:ext cx="256032" cy="6858000"/>
+            <a:off x="1115568" y="2240279"/>
+            <a:ext cx="457200" cy="109728"/>
           </a:xfrm>
           <a:prstGeom prst="rect">
             <a:avLst/>
@@ -8869,23 +9440,80 @@
       </p:sp>
       <p:sp>
         <p:nvSpPr>
-          <p:cNvPr id="5" name="Rectangle 4"/>
+          <p:cNvPr id="7" name="TextBox 6"/>
+          <p:cNvSpPr txBox="1"/>
+          <p:nvPr/>
+        </p:nvSpPr>
+        <p:spPr>
+          <a:xfrm>
+            <a:off x="1097280" y="2468880"/>
+            <a:ext cx="2880360" cy="1371599"/>
+          </a:xfrm>
+          <a:prstGeom prst="rect">
+            <a:avLst/>
+          </a:prstGeom>
+          <a:noFill/>
+        </p:spPr>
+        <p:txBody>
+          <a:bodyPr wrap="square">
+            <a:spAutoFit/>
+          </a:bodyPr>
+          <a:lstStyle/>
+          <a:p>
+            <a:pPr algn="l">
+              <a:spcAft>
+                <a:spcPts val="600"/>
+              </a:spcAft>
+            </a:pPr>
+            <a:r>
+              <a:rPr sz="1550" b="1" i="0">
+                <a:solidFill>
+                  <a:srgbClr val="1B2B3A"/>
+                </a:solidFill>
+                <a:latin typeface="Calibri"/>
+              </a:rPr>
+              <a:t>Prévisionnel de CA 12 mois</a:t>
+            </a:r>
+          </a:p>
+          <a:p>
+            <a:pPr algn="l">
+              <a:spcAft>
+                <a:spcPts val="600"/>
+              </a:spcAft>
+            </a:pPr>
+            <a:r>
+              <a:rPr sz="1200" b="0" i="0">
+                <a:solidFill>
+                  <a:srgbClr val="647485"/>
+                </a:solidFill>
+                <a:latin typeface="Calibri"/>
+              </a:rPr>
+              <a:t>Backlog des missions + pipeline pondéré, projetés mois par mois.</a:t>
+            </a:r>
+          </a:p>
+        </p:txBody>
+      </p:sp>
+      <p:sp>
+        <p:nvSpPr>
+          <p:cNvPr id="8" name="Rounded Rectangle 7"/>
           <p:cNvSpPr/>
           <p:nvPr/>
         </p:nvSpPr>
         <p:spPr>
           <a:xfrm>
-            <a:off x="914400" y="987552"/>
-            <a:ext cx="82296" cy="146304"/>
-          </a:xfrm>
-          <a:prstGeom prst="rect">
+            <a:off x="4526280" y="1965960"/>
+            <a:ext cx="3429000" cy="2103120"/>
+          </a:xfrm>
+          <a:prstGeom prst="roundRect">
             <a:avLst/>
           </a:prstGeom>
           <a:solidFill>
-            <a:srgbClr val="FFFFFF"/>
+            <a:srgbClr val="F7F9FB"/>
           </a:solidFill>
-          <a:ln>
-            <a:noFill/>
+          <a:ln w="12700">
+            <a:solidFill>
+              <a:srgbClr val="E2E8F0"/>
+            </a:solidFill>
           </a:ln>
           <a:effectLst/>
         </p:spPr>
@@ -8913,58 +9541,14 @@
       </p:sp>
       <p:sp>
         <p:nvSpPr>
-          <p:cNvPr id="6" name="Rectangle 5"/>
+          <p:cNvPr id="9" name="Rectangle 8"/>
           <p:cNvSpPr/>
           <p:nvPr/>
         </p:nvSpPr>
         <p:spPr>
           <a:xfrm>
-            <a:off x="1033271" y="914400"/>
-            <a:ext cx="82296" cy="219456"/>
-          </a:xfrm>
-          <a:prstGeom prst="rect">
-            <a:avLst/>
-          </a:prstGeom>
-          <a:solidFill>
-            <a:srgbClr val="FFFFFF"/>
-          </a:solidFill>
-          <a:ln>
-            <a:noFill/>
-          </a:ln>
-          <a:effectLst/>
-        </p:spPr>
-        <p:style>
-          <a:lnRef idx="1">
-            <a:schemeClr val="accent1"/>
-          </a:lnRef>
-          <a:fillRef idx="3">
-            <a:schemeClr val="accent1"/>
-          </a:fillRef>
-          <a:effectRef idx="2">
-            <a:schemeClr val="accent1"/>
-          </a:effectRef>
-          <a:fontRef idx="minor">
-            <a:schemeClr val="lt1"/>
-          </a:fontRef>
-        </p:style>
-        <p:txBody>
-          <a:bodyPr rtlCol="0" anchor="ctr"/>
-          <a:lstStyle/>
-          <a:p>
-            <a:pPr algn="ctr"/>
-          </a:p>
-        </p:txBody>
-      </p:sp>
-      <p:sp>
-        <p:nvSpPr>
-          <p:cNvPr id="7" name="Rectangle 6"/>
-          <p:cNvSpPr/>
-          <p:nvPr/>
-        </p:nvSpPr>
-        <p:spPr>
-          <a:xfrm>
-            <a:off x="1152143" y="822959"/>
-            <a:ext cx="82296" cy="310896"/>
+            <a:off x="4818888" y="2240279"/>
+            <a:ext cx="457200" cy="109728"/>
           </a:xfrm>
           <a:prstGeom prst="rect">
             <a:avLst/>
@@ -9001,14 +9585,14 @@
       </p:sp>
       <p:sp>
         <p:nvSpPr>
-          <p:cNvPr id="8" name="TextBox 7"/>
+          <p:cNvPr id="10" name="TextBox 9"/>
           <p:cNvSpPr txBox="1"/>
           <p:nvPr/>
         </p:nvSpPr>
         <p:spPr>
           <a:xfrm>
-            <a:off x="1371600" y="768096"/>
-            <a:ext cx="2743200" cy="457200"/>
+            <a:off x="4800600" y="2468880"/>
+            <a:ext cx="2880360" cy="1371599"/>
           </a:xfrm>
           <a:prstGeom prst="rect">
             <a:avLst/>
@@ -9027,84 +9611,91 @@
               </a:spcAft>
             </a:pPr>
             <a:r>
-              <a:rPr sz="2000" b="1" i="0">
-                <a:solidFill>
-                  <a:srgbClr val="FFFFFF"/>
-                </a:solidFill>
-                <a:latin typeface="Calibri"/>
-              </a:rPr>
-              <a:t>Konsilys</a:t>
-            </a:r>
-          </a:p>
-        </p:txBody>
-      </p:sp>
-      <p:sp>
-        <p:nvSpPr>
-          <p:cNvPr id="9" name="TextBox 8"/>
-          <p:cNvSpPr txBox="1"/>
-          <p:nvPr/>
-        </p:nvSpPr>
-        <p:spPr>
-          <a:xfrm>
-            <a:off x="868680" y="2377440"/>
-            <a:ext cx="10424160" cy="1828800"/>
+              <a:rPr sz="1550" b="1" i="0">
+                <a:solidFill>
+                  <a:srgbClr val="1B2B3A"/>
+                </a:solidFill>
+                <a:latin typeface="Calibri"/>
+              </a:rPr>
+              <a:t>Marge consolidée par BU / Practice</a:t>
+            </a:r>
+          </a:p>
+          <a:p>
+            <a:pPr algn="l">
+              <a:spcAft>
+                <a:spcPts val="600"/>
+              </a:spcAft>
+            </a:pPr>
+            <a:r>
+              <a:rPr sz="1200" b="0" i="0">
+                <a:solidFill>
+                  <a:srgbClr val="647485"/>
+                </a:solidFill>
+                <a:latin typeface="Calibri"/>
+              </a:rPr>
+              <a:t>Rentabilité par entité, du groupe jusqu'à l'équipe.</a:t>
+            </a:r>
+          </a:p>
+        </p:txBody>
+      </p:sp>
+      <p:sp>
+        <p:nvSpPr>
+          <p:cNvPr id="11" name="Rounded Rectangle 10"/>
+          <p:cNvSpPr/>
+          <p:nvPr/>
+        </p:nvSpPr>
+        <p:spPr>
+          <a:xfrm>
+            <a:off x="8229600" y="1965960"/>
+            <a:ext cx="3429000" cy="2103120"/>
+          </a:xfrm>
+          <a:prstGeom prst="roundRect">
+            <a:avLst/>
+          </a:prstGeom>
+          <a:solidFill>
+            <a:srgbClr val="F7F9FB"/>
+          </a:solidFill>
+          <a:ln w="12700">
+            <a:solidFill>
+              <a:srgbClr val="E2E8F0"/>
+            </a:solidFill>
+          </a:ln>
+          <a:effectLst/>
+        </p:spPr>
+        <p:style>
+          <a:lnRef idx="1">
+            <a:schemeClr val="accent1"/>
+          </a:lnRef>
+          <a:fillRef idx="3">
+            <a:schemeClr val="accent1"/>
+          </a:fillRef>
+          <a:effectRef idx="2">
+            <a:schemeClr val="accent1"/>
+          </a:effectRef>
+          <a:fontRef idx="minor">
+            <a:schemeClr val="lt1"/>
+          </a:fontRef>
+        </p:style>
+        <p:txBody>
+          <a:bodyPr rtlCol="0" anchor="ctr"/>
+          <a:lstStyle/>
+          <a:p>
+            <a:pPr algn="ctr"/>
+          </a:p>
+        </p:txBody>
+      </p:sp>
+      <p:sp>
+        <p:nvSpPr>
+          <p:cNvPr id="12" name="Rectangle 11"/>
+          <p:cNvSpPr/>
+          <p:nvPr/>
+        </p:nvSpPr>
+        <p:spPr>
+          <a:xfrm>
+            <a:off x="8522208" y="2240279"/>
+            <a:ext cx="457200" cy="109728"/>
           </a:xfrm>
           <a:prstGeom prst="rect">
-            <a:avLst/>
-          </a:prstGeom>
-          <a:noFill/>
-        </p:spPr>
-        <p:txBody>
-          <a:bodyPr wrap="square">
-            <a:spAutoFit/>
-          </a:bodyPr>
-          <a:lstStyle/>
-          <a:p>
-            <a:pPr algn="l">
-              <a:spcAft>
-                <a:spcPts val="1000"/>
-              </a:spcAft>
-            </a:pPr>
-            <a:r>
-              <a:rPr sz="3800" b="1" i="0">
-                <a:solidFill>
-                  <a:srgbClr val="FFFFFF"/>
-                </a:solidFill>
-                <a:latin typeface="Calibri"/>
-              </a:rPr>
-              <a:t>Prêt à piloter votre ESN autrement ?</a:t>
-            </a:r>
-          </a:p>
-          <a:p>
-            <a:pPr algn="l">
-              <a:spcAft>
-                <a:spcPts val="600"/>
-              </a:spcAft>
-            </a:pPr>
-            <a:r>
-              <a:rPr sz="1800" b="0" i="0">
-                <a:solidFill>
-                  <a:srgbClr val="C7D2DD"/>
-                </a:solidFill>
-                <a:latin typeface="Calibri"/>
-              </a:rPr>
-              <a:t>Souscrivez en ligne dès aujourd'hui, ou demandez une démonstration personnalisée avec vos propres données.</a:t>
-            </a:r>
-          </a:p>
-        </p:txBody>
-      </p:sp>
-      <p:sp>
-        <p:nvSpPr>
-          <p:cNvPr id="10" name="Rounded Rectangle 9"/>
-          <p:cNvSpPr/>
-          <p:nvPr/>
-        </p:nvSpPr>
-        <p:spPr>
-          <a:xfrm>
-            <a:off x="868680" y="4480560"/>
-            <a:ext cx="3017520" cy="777240"/>
-          </a:xfrm>
-          <a:prstGeom prst="roundRect">
             <a:avLst/>
           </a:prstGeom>
           <a:solidFill>
@@ -9133,33 +9724,20 @@
           <a:bodyPr rtlCol="0" anchor="ctr"/>
           <a:lstStyle/>
           <a:p>
-            <a:pPr algn="ctr">
-              <a:spcAft>
-                <a:spcPts val="600"/>
-              </a:spcAft>
-            </a:pPr>
-            <a:r>
-              <a:rPr sz="1800" b="1" i="0">
-                <a:solidFill>
-                  <a:srgbClr val="1B2B3A"/>
-                </a:solidFill>
-                <a:latin typeface="Calibri"/>
-              </a:rPr>
-              <a:t>konsilys.fr</a:t>
-            </a:r>
-          </a:p>
-        </p:txBody>
-      </p:sp>
-      <p:sp>
-        <p:nvSpPr>
-          <p:cNvPr id="11" name="TextBox 10"/>
+            <a:pPr algn="ctr"/>
+          </a:p>
+        </p:txBody>
+      </p:sp>
+      <p:sp>
+        <p:nvSpPr>
+          <p:cNvPr id="13" name="TextBox 12"/>
           <p:cNvSpPr txBox="1"/>
           <p:nvPr/>
         </p:nvSpPr>
         <p:spPr>
           <a:xfrm>
-            <a:off x="4206240" y="4617720"/>
-            <a:ext cx="6400800" cy="640080"/>
+            <a:off x="8503920" y="2468880"/>
+            <a:ext cx="2880360" cy="1371599"/>
           </a:xfrm>
           <a:prstGeom prst="rect">
             <a:avLst/>
@@ -9178,13 +9756,503 @@
               </a:spcAft>
             </a:pPr>
             <a:r>
-              <a:rPr sz="1800" b="1" i="0">
-                <a:solidFill>
-                  <a:srgbClr val="FFFFFF"/>
-                </a:solidFill>
-                <a:latin typeface="Calibri"/>
-              </a:rPr>
-              <a:t>contact@konsilys.fr</a:t>
+              <a:rPr sz="1550" b="1" i="0">
+                <a:solidFill>
+                  <a:srgbClr val="1B2B3A"/>
+                </a:solidFill>
+                <a:latin typeface="Calibri"/>
+              </a:rPr>
+              <a:t>Hiérarchie multi-BU (6 niveaux)</a:t>
+            </a:r>
+          </a:p>
+          <a:p>
+            <a:pPr algn="l">
+              <a:spcAft>
+                <a:spcPts val="600"/>
+              </a:spcAft>
+            </a:pPr>
+            <a:r>
+              <a:rPr sz="1200" b="0" i="0">
+                <a:solidFill>
+                  <a:srgbClr val="647485"/>
+                </a:solidFill>
+                <a:latin typeface="Calibri"/>
+              </a:rPr>
+              <a:t>Monde › région › agence › équipe. Un nouveau compte hérite de la BU de son créateur.</a:t>
+            </a:r>
+          </a:p>
+        </p:txBody>
+      </p:sp>
+      <p:sp>
+        <p:nvSpPr>
+          <p:cNvPr id="14" name="Rounded Rectangle 13"/>
+          <p:cNvSpPr/>
+          <p:nvPr/>
+        </p:nvSpPr>
+        <p:spPr>
+          <a:xfrm>
+            <a:off x="822960" y="4343400"/>
+            <a:ext cx="3429000" cy="2103120"/>
+          </a:xfrm>
+          <a:prstGeom prst="roundRect">
+            <a:avLst/>
+          </a:prstGeom>
+          <a:solidFill>
+            <a:srgbClr val="F7F9FB"/>
+          </a:solidFill>
+          <a:ln w="12700">
+            <a:solidFill>
+              <a:srgbClr val="E2E8F0"/>
+            </a:solidFill>
+          </a:ln>
+          <a:effectLst/>
+        </p:spPr>
+        <p:style>
+          <a:lnRef idx="1">
+            <a:schemeClr val="accent1"/>
+          </a:lnRef>
+          <a:fillRef idx="3">
+            <a:schemeClr val="accent1"/>
+          </a:fillRef>
+          <a:effectRef idx="2">
+            <a:schemeClr val="accent1"/>
+          </a:effectRef>
+          <a:fontRef idx="minor">
+            <a:schemeClr val="lt1"/>
+          </a:fontRef>
+        </p:style>
+        <p:txBody>
+          <a:bodyPr rtlCol="0" anchor="ctr"/>
+          <a:lstStyle/>
+          <a:p>
+            <a:pPr algn="ctr"/>
+          </a:p>
+        </p:txBody>
+      </p:sp>
+      <p:sp>
+        <p:nvSpPr>
+          <p:cNvPr id="15" name="Rectangle 14"/>
+          <p:cNvSpPr/>
+          <p:nvPr/>
+        </p:nvSpPr>
+        <p:spPr>
+          <a:xfrm>
+            <a:off x="1115568" y="4617720"/>
+            <a:ext cx="457200" cy="109728"/>
+          </a:xfrm>
+          <a:prstGeom prst="rect">
+            <a:avLst/>
+          </a:prstGeom>
+          <a:solidFill>
+            <a:srgbClr val="84CC16"/>
+          </a:solidFill>
+          <a:ln>
+            <a:noFill/>
+          </a:ln>
+          <a:effectLst/>
+        </p:spPr>
+        <p:style>
+          <a:lnRef idx="1">
+            <a:schemeClr val="accent1"/>
+          </a:lnRef>
+          <a:fillRef idx="3">
+            <a:schemeClr val="accent1"/>
+          </a:fillRef>
+          <a:effectRef idx="2">
+            <a:schemeClr val="accent1"/>
+          </a:effectRef>
+          <a:fontRef idx="minor">
+            <a:schemeClr val="lt1"/>
+          </a:fontRef>
+        </p:style>
+        <p:txBody>
+          <a:bodyPr rtlCol="0" anchor="ctr"/>
+          <a:lstStyle/>
+          <a:p>
+            <a:pPr algn="ctr"/>
+          </a:p>
+        </p:txBody>
+      </p:sp>
+      <p:sp>
+        <p:nvSpPr>
+          <p:cNvPr id="16" name="TextBox 15"/>
+          <p:cNvSpPr txBox="1"/>
+          <p:nvPr/>
+        </p:nvSpPr>
+        <p:spPr>
+          <a:xfrm>
+            <a:off x="1097280" y="4846320"/>
+            <a:ext cx="2880360" cy="1371599"/>
+          </a:xfrm>
+          <a:prstGeom prst="rect">
+            <a:avLst/>
+          </a:prstGeom>
+          <a:noFill/>
+        </p:spPr>
+        <p:txBody>
+          <a:bodyPr wrap="square">
+            <a:spAutoFit/>
+          </a:bodyPr>
+          <a:lstStyle/>
+          <a:p>
+            <a:pPr algn="l">
+              <a:spcAft>
+                <a:spcPts val="600"/>
+              </a:spcAft>
+            </a:pPr>
+            <a:r>
+              <a:rPr sz="1550" b="1" i="0">
+                <a:solidFill>
+                  <a:srgbClr val="1B2B3A"/>
+                </a:solidFill>
+                <a:latin typeface="Calibri"/>
+              </a:rPr>
+              <a:t>Recrutement intelligent</a:t>
+            </a:r>
+          </a:p>
+          <a:p>
+            <a:pPr algn="l">
+              <a:spcAft>
+                <a:spcPts val="600"/>
+              </a:spcAft>
+            </a:pPr>
+            <a:r>
+              <a:rPr sz="1200" b="0" i="0">
+                <a:solidFill>
+                  <a:srgbClr val="647485"/>
+                </a:solidFill>
+                <a:latin typeface="Calibri"/>
+              </a:rPr>
+              <a:t>Pipeline partagé + matching expertise / localisation / expérience / secteur ; localisation cible, secondaire et mobilité.</a:t>
+            </a:r>
+          </a:p>
+        </p:txBody>
+      </p:sp>
+      <p:sp>
+        <p:nvSpPr>
+          <p:cNvPr id="17" name="Rounded Rectangle 16"/>
+          <p:cNvSpPr/>
+          <p:nvPr/>
+        </p:nvSpPr>
+        <p:spPr>
+          <a:xfrm>
+            <a:off x="4526280" y="4343400"/>
+            <a:ext cx="3429000" cy="2103120"/>
+          </a:xfrm>
+          <a:prstGeom prst="roundRect">
+            <a:avLst/>
+          </a:prstGeom>
+          <a:solidFill>
+            <a:srgbClr val="F7F9FB"/>
+          </a:solidFill>
+          <a:ln w="12700">
+            <a:solidFill>
+              <a:srgbClr val="E2E8F0"/>
+            </a:solidFill>
+          </a:ln>
+          <a:effectLst/>
+        </p:spPr>
+        <p:style>
+          <a:lnRef idx="1">
+            <a:schemeClr val="accent1"/>
+          </a:lnRef>
+          <a:fillRef idx="3">
+            <a:schemeClr val="accent1"/>
+          </a:fillRef>
+          <a:effectRef idx="2">
+            <a:schemeClr val="accent1"/>
+          </a:effectRef>
+          <a:fontRef idx="minor">
+            <a:schemeClr val="lt1"/>
+          </a:fontRef>
+        </p:style>
+        <p:txBody>
+          <a:bodyPr rtlCol="0" anchor="ctr"/>
+          <a:lstStyle/>
+          <a:p>
+            <a:pPr algn="ctr"/>
+          </a:p>
+        </p:txBody>
+      </p:sp>
+      <p:sp>
+        <p:nvSpPr>
+          <p:cNvPr id="18" name="Rectangle 17"/>
+          <p:cNvSpPr/>
+          <p:nvPr/>
+        </p:nvSpPr>
+        <p:spPr>
+          <a:xfrm>
+            <a:off x="4818888" y="4617720"/>
+            <a:ext cx="457200" cy="109728"/>
+          </a:xfrm>
+          <a:prstGeom prst="rect">
+            <a:avLst/>
+          </a:prstGeom>
+          <a:solidFill>
+            <a:srgbClr val="84CC16"/>
+          </a:solidFill>
+          <a:ln>
+            <a:noFill/>
+          </a:ln>
+          <a:effectLst/>
+        </p:spPr>
+        <p:style>
+          <a:lnRef idx="1">
+            <a:schemeClr val="accent1"/>
+          </a:lnRef>
+          <a:fillRef idx="3">
+            <a:schemeClr val="accent1"/>
+          </a:fillRef>
+          <a:effectRef idx="2">
+            <a:schemeClr val="accent1"/>
+          </a:effectRef>
+          <a:fontRef idx="minor">
+            <a:schemeClr val="lt1"/>
+          </a:fontRef>
+        </p:style>
+        <p:txBody>
+          <a:bodyPr rtlCol="0" anchor="ctr"/>
+          <a:lstStyle/>
+          <a:p>
+            <a:pPr algn="ctr"/>
+          </a:p>
+        </p:txBody>
+      </p:sp>
+      <p:sp>
+        <p:nvSpPr>
+          <p:cNvPr id="19" name="TextBox 18"/>
+          <p:cNvSpPr txBox="1"/>
+          <p:nvPr/>
+        </p:nvSpPr>
+        <p:spPr>
+          <a:xfrm>
+            <a:off x="4800600" y="4846320"/>
+            <a:ext cx="2880360" cy="1371599"/>
+          </a:xfrm>
+          <a:prstGeom prst="rect">
+            <a:avLst/>
+          </a:prstGeom>
+          <a:noFill/>
+        </p:spPr>
+        <p:txBody>
+          <a:bodyPr wrap="square">
+            <a:spAutoFit/>
+          </a:bodyPr>
+          <a:lstStyle/>
+          <a:p>
+            <a:pPr algn="l">
+              <a:spcAft>
+                <a:spcPts val="600"/>
+              </a:spcAft>
+            </a:pPr>
+            <a:r>
+              <a:rPr sz="1550" b="1" i="0">
+                <a:solidFill>
+                  <a:srgbClr val="1B2B3A"/>
+                </a:solidFill>
+                <a:latin typeface="Calibri"/>
+              </a:rPr>
+              <a:t>Sécurité de niveau entreprise</a:t>
+            </a:r>
+          </a:p>
+          <a:p>
+            <a:pPr algn="l">
+              <a:spcAft>
+                <a:spcPts val="600"/>
+              </a:spcAft>
+            </a:pPr>
+            <a:r>
+              <a:rPr sz="1200" b="0" i="0">
+                <a:solidFill>
+                  <a:srgbClr val="647485"/>
+                </a:solidFill>
+                <a:latin typeface="Calibri"/>
+              </a:rPr>
+              <a:t>Isolation RLS auditée, journal d'audit horodaté, permissions fines — conformité RGPD.</a:t>
+            </a:r>
+          </a:p>
+        </p:txBody>
+      </p:sp>
+      <p:sp>
+        <p:nvSpPr>
+          <p:cNvPr id="20" name="Rounded Rectangle 19"/>
+          <p:cNvSpPr/>
+          <p:nvPr/>
+        </p:nvSpPr>
+        <p:spPr>
+          <a:xfrm>
+            <a:off x="8229600" y="4343400"/>
+            <a:ext cx="3429000" cy="2103120"/>
+          </a:xfrm>
+          <a:prstGeom prst="roundRect">
+            <a:avLst/>
+          </a:prstGeom>
+          <a:solidFill>
+            <a:srgbClr val="F7F9FB"/>
+          </a:solidFill>
+          <a:ln w="12700">
+            <a:solidFill>
+              <a:srgbClr val="E2E8F0"/>
+            </a:solidFill>
+          </a:ln>
+          <a:effectLst/>
+        </p:spPr>
+        <p:style>
+          <a:lnRef idx="1">
+            <a:schemeClr val="accent1"/>
+          </a:lnRef>
+          <a:fillRef idx="3">
+            <a:schemeClr val="accent1"/>
+          </a:fillRef>
+          <a:effectRef idx="2">
+            <a:schemeClr val="accent1"/>
+          </a:effectRef>
+          <a:fontRef idx="minor">
+            <a:schemeClr val="lt1"/>
+          </a:fontRef>
+        </p:style>
+        <p:txBody>
+          <a:bodyPr rtlCol="0" anchor="ctr"/>
+          <a:lstStyle/>
+          <a:p>
+            <a:pPr algn="ctr"/>
+          </a:p>
+        </p:txBody>
+      </p:sp>
+      <p:sp>
+        <p:nvSpPr>
+          <p:cNvPr id="21" name="Rectangle 20"/>
+          <p:cNvSpPr/>
+          <p:nvPr/>
+        </p:nvSpPr>
+        <p:spPr>
+          <a:xfrm>
+            <a:off x="8522208" y="4617720"/>
+            <a:ext cx="457200" cy="109728"/>
+          </a:xfrm>
+          <a:prstGeom prst="rect">
+            <a:avLst/>
+          </a:prstGeom>
+          <a:solidFill>
+            <a:srgbClr val="84CC16"/>
+          </a:solidFill>
+          <a:ln>
+            <a:noFill/>
+          </a:ln>
+          <a:effectLst/>
+        </p:spPr>
+        <p:style>
+          <a:lnRef idx="1">
+            <a:schemeClr val="accent1"/>
+          </a:lnRef>
+          <a:fillRef idx="3">
+            <a:schemeClr val="accent1"/>
+          </a:fillRef>
+          <a:effectRef idx="2">
+            <a:schemeClr val="accent1"/>
+          </a:effectRef>
+          <a:fontRef idx="minor">
+            <a:schemeClr val="lt1"/>
+          </a:fontRef>
+        </p:style>
+        <p:txBody>
+          <a:bodyPr rtlCol="0" anchor="ctr"/>
+          <a:lstStyle/>
+          <a:p>
+            <a:pPr algn="ctr"/>
+          </a:p>
+        </p:txBody>
+      </p:sp>
+      <p:sp>
+        <p:nvSpPr>
+          <p:cNvPr id="22" name="TextBox 21"/>
+          <p:cNvSpPr txBox="1"/>
+          <p:nvPr/>
+        </p:nvSpPr>
+        <p:spPr>
+          <a:xfrm>
+            <a:off x="8503920" y="4846320"/>
+            <a:ext cx="2880360" cy="1371599"/>
+          </a:xfrm>
+          <a:prstGeom prst="rect">
+            <a:avLst/>
+          </a:prstGeom>
+          <a:noFill/>
+        </p:spPr>
+        <p:txBody>
+          <a:bodyPr wrap="square">
+            <a:spAutoFit/>
+          </a:bodyPr>
+          <a:lstStyle/>
+          <a:p>
+            <a:pPr algn="l">
+              <a:spcAft>
+                <a:spcPts val="600"/>
+              </a:spcAft>
+            </a:pPr>
+            <a:r>
+              <a:rPr sz="1550" b="1" i="0">
+                <a:solidFill>
+                  <a:srgbClr val="1B2B3A"/>
+                </a:solidFill>
+                <a:latin typeface="Calibri"/>
+              </a:rPr>
+              <a:t>Robustesse</a:t>
+            </a:r>
+          </a:p>
+          <a:p>
+            <a:pPr algn="l">
+              <a:spcAft>
+                <a:spcPts val="600"/>
+              </a:spcAft>
+            </a:pPr>
+            <a:r>
+              <a:rPr sz="1200" b="0" i="0">
+                <a:solidFill>
+                  <a:srgbClr val="647485"/>
+                </a:solidFill>
+                <a:latin typeface="Calibri"/>
+              </a:rPr>
+              <a:t>Base de code modulaire et tests automatisés de non-régression.</a:t>
+            </a:r>
+          </a:p>
+        </p:txBody>
+      </p:sp>
+      <p:sp>
+        <p:nvSpPr>
+          <p:cNvPr id="23" name="TextBox 22"/>
+          <p:cNvSpPr txBox="1"/>
+          <p:nvPr/>
+        </p:nvSpPr>
+        <p:spPr>
+          <a:xfrm>
+            <a:off x="11247120" y="6419088"/>
+            <a:ext cx="822960" cy="365760"/>
+          </a:xfrm>
+          <a:prstGeom prst="rect">
+            <a:avLst/>
+          </a:prstGeom>
+          <a:noFill/>
+        </p:spPr>
+        <p:txBody>
+          <a:bodyPr wrap="square">
+            <a:spAutoFit/>
+          </a:bodyPr>
+          <a:lstStyle/>
+          <a:p>
+            <a:pPr algn="r">
+              <a:spcAft>
+                <a:spcPts val="600"/>
+              </a:spcAft>
+            </a:pPr>
+            <a:r>
+              <a:rPr sz="1000" b="0" i="0">
+                <a:solidFill>
+                  <a:srgbClr val="647485"/>
+                </a:solidFill>
+                <a:latin typeface="Calibri"/>
+              </a:rPr>
+              <a:t>9</a:t>
             </a:r>
           </a:p>
         </p:txBody>

</xml_diff>

<commit_message>
Livrables : présentations + spécifications mises à jour (#36)
- Prospection & Investisseur : nouvelle slide « Grands comptes / groupes
  multi-BU » (prévisionnel 12 mois, marge consolidée BU/Practice, hiérarchie
  6 niveaux, recrutement intelligent + localisation/mobilité, sécurité RGPD
  auditée, robustesse). PPTX + PDF régénérés.
- Spécifications : nouvelle section 13 « Évolutions récentes » (durcissement
  sécurité/RGPD + audit log, pilotage/prévisionnel, multi-BU, recrutement
  pipeline partagé + matching + localisation classifiée + mobilité régionale,
  qualité/tests). DOCX + PDF régénérés.


Claude-Session: https://claude.ai/code/session_01USvXvdfgNeVsVaFCtcwkou

Co-authored-by: Claude <noreply@anthropic.com>
</commit_message>
<xml_diff>
--- a/deliverables/Konsilys_Presentation_Prospection.pptx
+++ b/deliverables/Konsilys_Presentation_Prospection.pptx
@@ -14,6 +14,7 @@
     <p:sldId id="262" r:id="rId13"/>
     <p:sldId id="263" r:id="rId14"/>
     <p:sldId id="264" r:id="rId15"/>
+    <p:sldId id="265" r:id="rId16"/>
   </p:sldIdLst>
   <p:sldSz cx="12191695" cy="6858000" type="screen4x3"/>
   <p:notesSz cx="6858000" cy="9144000"/>
@@ -3574,6 +3575,478 @@
 </p:sld>
 </file>
 
+<file path=ppt/slides/slide10.xml><?xml version="1.0" encoding="utf-8"?>
+<p:sld xmlns:a="http://schemas.openxmlformats.org/drawingml/2006/main" xmlns:p="http://schemas.openxmlformats.org/presentationml/2006/main" xmlns:r="http://schemas.openxmlformats.org/officeDocument/2006/relationships">
+  <p:cSld>
+    <p:spTree>
+      <p:nvGrpSpPr>
+        <p:cNvPr id="1" name=""/>
+        <p:cNvGrpSpPr/>
+        <p:nvPr/>
+      </p:nvGrpSpPr>
+      <p:grpSpPr/>
+      <p:sp>
+        <p:nvSpPr>
+          <p:cNvPr id="2" name="Rectangle 1"/>
+          <p:cNvSpPr/>
+          <p:nvPr/>
+        </p:nvSpPr>
+        <p:spPr>
+          <a:xfrm>
+            <a:off x="0" y="0"/>
+            <a:ext cx="12191695" cy="6858000"/>
+          </a:xfrm>
+          <a:prstGeom prst="rect">
+            <a:avLst/>
+          </a:prstGeom>
+          <a:solidFill>
+            <a:srgbClr val="1B2B3A"/>
+          </a:solidFill>
+          <a:ln>
+            <a:noFill/>
+          </a:ln>
+          <a:effectLst/>
+        </p:spPr>
+        <p:style>
+          <a:lnRef idx="1">
+            <a:schemeClr val="accent1"/>
+          </a:lnRef>
+          <a:fillRef idx="3">
+            <a:schemeClr val="accent1"/>
+          </a:fillRef>
+          <a:effectRef idx="2">
+            <a:schemeClr val="accent1"/>
+          </a:effectRef>
+          <a:fontRef idx="minor">
+            <a:schemeClr val="lt1"/>
+          </a:fontRef>
+        </p:style>
+        <p:txBody>
+          <a:bodyPr rtlCol="0" anchor="ctr"/>
+          <a:lstStyle/>
+          <a:p>
+            <a:pPr algn="ctr"/>
+          </a:p>
+        </p:txBody>
+      </p:sp>
+      <p:sp>
+        <p:nvSpPr>
+          <p:cNvPr id="3" name="Rectangle 2"/>
+          <p:cNvSpPr/>
+          <p:nvPr/>
+        </p:nvSpPr>
+        <p:spPr>
+          <a:xfrm>
+            <a:off x="0" y="0"/>
+            <a:ext cx="12191695" cy="6858000"/>
+          </a:xfrm>
+          <a:prstGeom prst="rect">
+            <a:avLst/>
+          </a:prstGeom>
+          <a:solidFill>
+            <a:srgbClr val="1B2B3A"/>
+          </a:solidFill>
+          <a:ln>
+            <a:noFill/>
+          </a:ln>
+          <a:effectLst/>
+        </p:spPr>
+        <p:style>
+          <a:lnRef idx="1">
+            <a:schemeClr val="accent1"/>
+          </a:lnRef>
+          <a:fillRef idx="3">
+            <a:schemeClr val="accent1"/>
+          </a:fillRef>
+          <a:effectRef idx="2">
+            <a:schemeClr val="accent1"/>
+          </a:effectRef>
+          <a:fontRef idx="minor">
+            <a:schemeClr val="lt1"/>
+          </a:fontRef>
+        </p:style>
+        <p:txBody>
+          <a:bodyPr rtlCol="0" anchor="ctr"/>
+          <a:lstStyle/>
+          <a:p>
+            <a:pPr algn="ctr"/>
+          </a:p>
+        </p:txBody>
+      </p:sp>
+      <p:sp>
+        <p:nvSpPr>
+          <p:cNvPr id="4" name="Rectangle 3"/>
+          <p:cNvSpPr/>
+          <p:nvPr/>
+        </p:nvSpPr>
+        <p:spPr>
+          <a:xfrm>
+            <a:off x="0" y="0"/>
+            <a:ext cx="256032" cy="6858000"/>
+          </a:xfrm>
+          <a:prstGeom prst="rect">
+            <a:avLst/>
+          </a:prstGeom>
+          <a:solidFill>
+            <a:srgbClr val="84CC16"/>
+          </a:solidFill>
+          <a:ln>
+            <a:noFill/>
+          </a:ln>
+          <a:effectLst/>
+        </p:spPr>
+        <p:style>
+          <a:lnRef idx="1">
+            <a:schemeClr val="accent1"/>
+          </a:lnRef>
+          <a:fillRef idx="3">
+            <a:schemeClr val="accent1"/>
+          </a:fillRef>
+          <a:effectRef idx="2">
+            <a:schemeClr val="accent1"/>
+          </a:effectRef>
+          <a:fontRef idx="minor">
+            <a:schemeClr val="lt1"/>
+          </a:fontRef>
+        </p:style>
+        <p:txBody>
+          <a:bodyPr rtlCol="0" anchor="ctr"/>
+          <a:lstStyle/>
+          <a:p>
+            <a:pPr algn="ctr"/>
+          </a:p>
+        </p:txBody>
+      </p:sp>
+      <p:sp>
+        <p:nvSpPr>
+          <p:cNvPr id="5" name="Rectangle 4"/>
+          <p:cNvSpPr/>
+          <p:nvPr/>
+        </p:nvSpPr>
+        <p:spPr>
+          <a:xfrm>
+            <a:off x="914400" y="987552"/>
+            <a:ext cx="82296" cy="146304"/>
+          </a:xfrm>
+          <a:prstGeom prst="rect">
+            <a:avLst/>
+          </a:prstGeom>
+          <a:solidFill>
+            <a:srgbClr val="FFFFFF"/>
+          </a:solidFill>
+          <a:ln>
+            <a:noFill/>
+          </a:ln>
+          <a:effectLst/>
+        </p:spPr>
+        <p:style>
+          <a:lnRef idx="1">
+            <a:schemeClr val="accent1"/>
+          </a:lnRef>
+          <a:fillRef idx="3">
+            <a:schemeClr val="accent1"/>
+          </a:fillRef>
+          <a:effectRef idx="2">
+            <a:schemeClr val="accent1"/>
+          </a:effectRef>
+          <a:fontRef idx="minor">
+            <a:schemeClr val="lt1"/>
+          </a:fontRef>
+        </p:style>
+        <p:txBody>
+          <a:bodyPr rtlCol="0" anchor="ctr"/>
+          <a:lstStyle/>
+          <a:p>
+            <a:pPr algn="ctr"/>
+          </a:p>
+        </p:txBody>
+      </p:sp>
+      <p:sp>
+        <p:nvSpPr>
+          <p:cNvPr id="6" name="Rectangle 5"/>
+          <p:cNvSpPr/>
+          <p:nvPr/>
+        </p:nvSpPr>
+        <p:spPr>
+          <a:xfrm>
+            <a:off x="1033271" y="914400"/>
+            <a:ext cx="82296" cy="219456"/>
+          </a:xfrm>
+          <a:prstGeom prst="rect">
+            <a:avLst/>
+          </a:prstGeom>
+          <a:solidFill>
+            <a:srgbClr val="FFFFFF"/>
+          </a:solidFill>
+          <a:ln>
+            <a:noFill/>
+          </a:ln>
+          <a:effectLst/>
+        </p:spPr>
+        <p:style>
+          <a:lnRef idx="1">
+            <a:schemeClr val="accent1"/>
+          </a:lnRef>
+          <a:fillRef idx="3">
+            <a:schemeClr val="accent1"/>
+          </a:fillRef>
+          <a:effectRef idx="2">
+            <a:schemeClr val="accent1"/>
+          </a:effectRef>
+          <a:fontRef idx="minor">
+            <a:schemeClr val="lt1"/>
+          </a:fontRef>
+        </p:style>
+        <p:txBody>
+          <a:bodyPr rtlCol="0" anchor="ctr"/>
+          <a:lstStyle/>
+          <a:p>
+            <a:pPr algn="ctr"/>
+          </a:p>
+        </p:txBody>
+      </p:sp>
+      <p:sp>
+        <p:nvSpPr>
+          <p:cNvPr id="7" name="Rectangle 6"/>
+          <p:cNvSpPr/>
+          <p:nvPr/>
+        </p:nvSpPr>
+        <p:spPr>
+          <a:xfrm>
+            <a:off x="1152143" y="822959"/>
+            <a:ext cx="82296" cy="310896"/>
+          </a:xfrm>
+          <a:prstGeom prst="rect">
+            <a:avLst/>
+          </a:prstGeom>
+          <a:solidFill>
+            <a:srgbClr val="84CC16"/>
+          </a:solidFill>
+          <a:ln>
+            <a:noFill/>
+          </a:ln>
+          <a:effectLst/>
+        </p:spPr>
+        <p:style>
+          <a:lnRef idx="1">
+            <a:schemeClr val="accent1"/>
+          </a:lnRef>
+          <a:fillRef idx="3">
+            <a:schemeClr val="accent1"/>
+          </a:fillRef>
+          <a:effectRef idx="2">
+            <a:schemeClr val="accent1"/>
+          </a:effectRef>
+          <a:fontRef idx="minor">
+            <a:schemeClr val="lt1"/>
+          </a:fontRef>
+        </p:style>
+        <p:txBody>
+          <a:bodyPr rtlCol="0" anchor="ctr"/>
+          <a:lstStyle/>
+          <a:p>
+            <a:pPr algn="ctr"/>
+          </a:p>
+        </p:txBody>
+      </p:sp>
+      <p:sp>
+        <p:nvSpPr>
+          <p:cNvPr id="8" name="TextBox 7"/>
+          <p:cNvSpPr txBox="1"/>
+          <p:nvPr/>
+        </p:nvSpPr>
+        <p:spPr>
+          <a:xfrm>
+            <a:off x="1371600" y="768096"/>
+            <a:ext cx="2743200" cy="457200"/>
+          </a:xfrm>
+          <a:prstGeom prst="rect">
+            <a:avLst/>
+          </a:prstGeom>
+          <a:noFill/>
+        </p:spPr>
+        <p:txBody>
+          <a:bodyPr wrap="square">
+            <a:spAutoFit/>
+          </a:bodyPr>
+          <a:lstStyle/>
+          <a:p>
+            <a:pPr algn="l">
+              <a:spcAft>
+                <a:spcPts val="600"/>
+              </a:spcAft>
+            </a:pPr>
+            <a:r>
+              <a:rPr sz="2000" b="1" i="0">
+                <a:solidFill>
+                  <a:srgbClr val="FFFFFF"/>
+                </a:solidFill>
+                <a:latin typeface="Calibri"/>
+              </a:rPr>
+              <a:t>Konsilys</a:t>
+            </a:r>
+          </a:p>
+        </p:txBody>
+      </p:sp>
+      <p:sp>
+        <p:nvSpPr>
+          <p:cNvPr id="9" name="TextBox 8"/>
+          <p:cNvSpPr txBox="1"/>
+          <p:nvPr/>
+        </p:nvSpPr>
+        <p:spPr>
+          <a:xfrm>
+            <a:off x="868680" y="2377440"/>
+            <a:ext cx="10424160" cy="1828800"/>
+          </a:xfrm>
+          <a:prstGeom prst="rect">
+            <a:avLst/>
+          </a:prstGeom>
+          <a:noFill/>
+        </p:spPr>
+        <p:txBody>
+          <a:bodyPr wrap="square">
+            <a:spAutoFit/>
+          </a:bodyPr>
+          <a:lstStyle/>
+          <a:p>
+            <a:pPr algn="l">
+              <a:spcAft>
+                <a:spcPts val="1000"/>
+              </a:spcAft>
+            </a:pPr>
+            <a:r>
+              <a:rPr sz="3800" b="1" i="0">
+                <a:solidFill>
+                  <a:srgbClr val="FFFFFF"/>
+                </a:solidFill>
+                <a:latin typeface="Calibri"/>
+              </a:rPr>
+              <a:t>Prêt à piloter votre ESN autrement ?</a:t>
+            </a:r>
+          </a:p>
+          <a:p>
+            <a:pPr algn="l">
+              <a:spcAft>
+                <a:spcPts val="600"/>
+              </a:spcAft>
+            </a:pPr>
+            <a:r>
+              <a:rPr sz="1800" b="0" i="0">
+                <a:solidFill>
+                  <a:srgbClr val="C7D2DD"/>
+                </a:solidFill>
+                <a:latin typeface="Calibri"/>
+              </a:rPr>
+              <a:t>Souscrivez en ligne dès aujourd'hui, ou demandez une démonstration personnalisée avec vos propres données.</a:t>
+            </a:r>
+          </a:p>
+        </p:txBody>
+      </p:sp>
+      <p:sp>
+        <p:nvSpPr>
+          <p:cNvPr id="10" name="Rounded Rectangle 9"/>
+          <p:cNvSpPr/>
+          <p:nvPr/>
+        </p:nvSpPr>
+        <p:spPr>
+          <a:xfrm>
+            <a:off x="868680" y="4480560"/>
+            <a:ext cx="3017520" cy="777240"/>
+          </a:xfrm>
+          <a:prstGeom prst="roundRect">
+            <a:avLst/>
+          </a:prstGeom>
+          <a:solidFill>
+            <a:srgbClr val="84CC16"/>
+          </a:solidFill>
+          <a:ln>
+            <a:noFill/>
+          </a:ln>
+          <a:effectLst/>
+        </p:spPr>
+        <p:style>
+          <a:lnRef idx="1">
+            <a:schemeClr val="accent1"/>
+          </a:lnRef>
+          <a:fillRef idx="3">
+            <a:schemeClr val="accent1"/>
+          </a:fillRef>
+          <a:effectRef idx="2">
+            <a:schemeClr val="accent1"/>
+          </a:effectRef>
+          <a:fontRef idx="minor">
+            <a:schemeClr val="lt1"/>
+          </a:fontRef>
+        </p:style>
+        <p:txBody>
+          <a:bodyPr rtlCol="0" anchor="ctr"/>
+          <a:lstStyle/>
+          <a:p>
+            <a:pPr algn="ctr">
+              <a:spcAft>
+                <a:spcPts val="600"/>
+              </a:spcAft>
+            </a:pPr>
+            <a:r>
+              <a:rPr sz="1800" b="1" i="0">
+                <a:solidFill>
+                  <a:srgbClr val="1B2B3A"/>
+                </a:solidFill>
+                <a:latin typeface="Calibri"/>
+              </a:rPr>
+              <a:t>konsilys.fr</a:t>
+            </a:r>
+          </a:p>
+        </p:txBody>
+      </p:sp>
+      <p:sp>
+        <p:nvSpPr>
+          <p:cNvPr id="11" name="TextBox 10"/>
+          <p:cNvSpPr txBox="1"/>
+          <p:nvPr/>
+        </p:nvSpPr>
+        <p:spPr>
+          <a:xfrm>
+            <a:off x="4206240" y="4617720"/>
+            <a:ext cx="6400800" cy="640080"/>
+          </a:xfrm>
+          <a:prstGeom prst="rect">
+            <a:avLst/>
+          </a:prstGeom>
+          <a:noFill/>
+        </p:spPr>
+        <p:txBody>
+          <a:bodyPr wrap="square">
+            <a:spAutoFit/>
+          </a:bodyPr>
+          <a:lstStyle/>
+          <a:p>
+            <a:pPr algn="l">
+              <a:spcAft>
+                <a:spcPts val="600"/>
+              </a:spcAft>
+            </a:pPr>
+            <a:r>
+              <a:rPr sz="1800" b="1" i="0">
+                <a:solidFill>
+                  <a:srgbClr val="FFFFFF"/>
+                </a:solidFill>
+                <a:latin typeface="Calibri"/>
+              </a:rPr>
+              <a:t>contact@konsilys.fr</a:t>
+            </a:r>
+          </a:p>
+        </p:txBody>
+      </p:sp>
+    </p:spTree>
+  </p:cSld>
+  <p:clrMapOvr>
+    <a:masterClrMapping/>
+  </p:clrMapOvr>
+</p:sld>
+</file>
+
 <file path=ppt/slides/slide2.xml><?xml version="1.0" encoding="utf-8"?>
 <p:sld xmlns:a="http://schemas.openxmlformats.org/drawingml/2006/main" xmlns:p="http://schemas.openxmlformats.org/presentationml/2006/main" xmlns:r="http://schemas.openxmlformats.org/officeDocument/2006/relationships">
   <p:cSld>
@@ -8750,7 +9223,7 @@
             <a:avLst/>
           </a:prstGeom>
           <a:solidFill>
-            <a:srgbClr val="1B2B3A"/>
+            <a:srgbClr val="FFFFFF"/>
           </a:solidFill>
           <a:ln>
             <a:noFill/>
@@ -8781,16 +9254,16 @@
       </p:sp>
       <p:sp>
         <p:nvSpPr>
-          <p:cNvPr id="3" name="Rectangle 2"/>
+          <p:cNvPr id="3" name="Rounded Rectangle 2"/>
           <p:cNvSpPr/>
           <p:nvPr/>
         </p:nvSpPr>
         <p:spPr>
           <a:xfrm>
-            <a:off x="0" y="0"/>
-            <a:ext cx="12191695" cy="6858000"/>
-          </a:xfrm>
-          <a:prstGeom prst="rect">
+            <a:off x="822960" y="594360"/>
+            <a:ext cx="2560320" cy="384048"/>
+          </a:xfrm>
+          <a:prstGeom prst="roundRect">
             <a:avLst/>
           </a:prstGeom>
           <a:solidFill>
@@ -8816,6 +9289,104 @@
           </a:fontRef>
         </p:style>
         <p:txBody>
+          <a:bodyPr rtlCol="0" anchor="ctr" wrap="square" tIns="25400" bIns="25400"/>
+          <a:lstStyle/>
+          <a:p>
+            <a:pPr algn="ctr">
+              <a:spcAft>
+                <a:spcPts val="600"/>
+              </a:spcAft>
+            </a:pPr>
+            <a:r>
+              <a:rPr sz="1100" b="1" i="0">
+                <a:solidFill>
+                  <a:srgbClr val="FFFFFF"/>
+                </a:solidFill>
+                <a:latin typeface="Calibri"/>
+              </a:rPr>
+              <a:t>GRANDS COMPTES</a:t>
+            </a:r>
+          </a:p>
+        </p:txBody>
+      </p:sp>
+      <p:sp>
+        <p:nvSpPr>
+          <p:cNvPr id="4" name="TextBox 3"/>
+          <p:cNvSpPr txBox="1"/>
+          <p:nvPr/>
+        </p:nvSpPr>
+        <p:spPr>
+          <a:xfrm>
+            <a:off x="822960" y="1005840"/>
+            <a:ext cx="10515600" cy="822960"/>
+          </a:xfrm>
+          <a:prstGeom prst="rect">
+            <a:avLst/>
+          </a:prstGeom>
+          <a:noFill/>
+        </p:spPr>
+        <p:txBody>
+          <a:bodyPr wrap="square">
+            <a:spAutoFit/>
+          </a:bodyPr>
+          <a:lstStyle/>
+          <a:p>
+            <a:pPr algn="l">
+              <a:spcAft>
+                <a:spcPts val="600"/>
+              </a:spcAft>
+            </a:pPr>
+            <a:r>
+              <a:rPr sz="3000" b="1" i="0">
+                <a:solidFill>
+                  <a:srgbClr val="1B2B3A"/>
+                </a:solidFill>
+                <a:latin typeface="Calibri"/>
+              </a:rPr>
+              <a:t>Conçu pour les groupes multi-BU</a:t>
+            </a:r>
+          </a:p>
+        </p:txBody>
+      </p:sp>
+      <p:sp>
+        <p:nvSpPr>
+          <p:cNvPr id="5" name="Rounded Rectangle 4"/>
+          <p:cNvSpPr/>
+          <p:nvPr/>
+        </p:nvSpPr>
+        <p:spPr>
+          <a:xfrm>
+            <a:off x="822960" y="1965960"/>
+            <a:ext cx="3429000" cy="2103120"/>
+          </a:xfrm>
+          <a:prstGeom prst="roundRect">
+            <a:avLst/>
+          </a:prstGeom>
+          <a:solidFill>
+            <a:srgbClr val="F7F9FB"/>
+          </a:solidFill>
+          <a:ln w="12700">
+            <a:solidFill>
+              <a:srgbClr val="E2E8F0"/>
+            </a:solidFill>
+          </a:ln>
+          <a:effectLst/>
+        </p:spPr>
+        <p:style>
+          <a:lnRef idx="1">
+            <a:schemeClr val="accent1"/>
+          </a:lnRef>
+          <a:fillRef idx="3">
+            <a:schemeClr val="accent1"/>
+          </a:fillRef>
+          <a:effectRef idx="2">
+            <a:schemeClr val="accent1"/>
+          </a:effectRef>
+          <a:fontRef idx="minor">
+            <a:schemeClr val="lt1"/>
+          </a:fontRef>
+        </p:style>
+        <p:txBody>
           <a:bodyPr rtlCol="0" anchor="ctr"/>
           <a:lstStyle/>
           <a:p>
@@ -8825,14 +9396,14 @@
       </p:sp>
       <p:sp>
         <p:nvSpPr>
-          <p:cNvPr id="4" name="Rectangle 3"/>
+          <p:cNvPr id="6" name="Rectangle 5"/>
           <p:cNvSpPr/>
           <p:nvPr/>
         </p:nvSpPr>
         <p:spPr>
           <a:xfrm>
-            <a:off x="0" y="0"/>
-            <a:ext cx="256032" cy="6858000"/>
+            <a:off x="1115568" y="2240279"/>
+            <a:ext cx="457200" cy="109728"/>
           </a:xfrm>
           <a:prstGeom prst="rect">
             <a:avLst/>
@@ -8869,23 +9440,80 @@
       </p:sp>
       <p:sp>
         <p:nvSpPr>
-          <p:cNvPr id="5" name="Rectangle 4"/>
+          <p:cNvPr id="7" name="TextBox 6"/>
+          <p:cNvSpPr txBox="1"/>
+          <p:nvPr/>
+        </p:nvSpPr>
+        <p:spPr>
+          <a:xfrm>
+            <a:off x="1097280" y="2468880"/>
+            <a:ext cx="2880360" cy="1371599"/>
+          </a:xfrm>
+          <a:prstGeom prst="rect">
+            <a:avLst/>
+          </a:prstGeom>
+          <a:noFill/>
+        </p:spPr>
+        <p:txBody>
+          <a:bodyPr wrap="square">
+            <a:spAutoFit/>
+          </a:bodyPr>
+          <a:lstStyle/>
+          <a:p>
+            <a:pPr algn="l">
+              <a:spcAft>
+                <a:spcPts val="600"/>
+              </a:spcAft>
+            </a:pPr>
+            <a:r>
+              <a:rPr sz="1550" b="1" i="0">
+                <a:solidFill>
+                  <a:srgbClr val="1B2B3A"/>
+                </a:solidFill>
+                <a:latin typeface="Calibri"/>
+              </a:rPr>
+              <a:t>Prévisionnel de CA 12 mois</a:t>
+            </a:r>
+          </a:p>
+          <a:p>
+            <a:pPr algn="l">
+              <a:spcAft>
+                <a:spcPts val="600"/>
+              </a:spcAft>
+            </a:pPr>
+            <a:r>
+              <a:rPr sz="1200" b="0" i="0">
+                <a:solidFill>
+                  <a:srgbClr val="647485"/>
+                </a:solidFill>
+                <a:latin typeface="Calibri"/>
+              </a:rPr>
+              <a:t>Backlog des missions + pipeline pondéré, projetés mois par mois.</a:t>
+            </a:r>
+          </a:p>
+        </p:txBody>
+      </p:sp>
+      <p:sp>
+        <p:nvSpPr>
+          <p:cNvPr id="8" name="Rounded Rectangle 7"/>
           <p:cNvSpPr/>
           <p:nvPr/>
         </p:nvSpPr>
         <p:spPr>
           <a:xfrm>
-            <a:off x="914400" y="987552"/>
-            <a:ext cx="82296" cy="146304"/>
-          </a:xfrm>
-          <a:prstGeom prst="rect">
+            <a:off x="4526280" y="1965960"/>
+            <a:ext cx="3429000" cy="2103120"/>
+          </a:xfrm>
+          <a:prstGeom prst="roundRect">
             <a:avLst/>
           </a:prstGeom>
           <a:solidFill>
-            <a:srgbClr val="FFFFFF"/>
+            <a:srgbClr val="F7F9FB"/>
           </a:solidFill>
-          <a:ln>
-            <a:noFill/>
+          <a:ln w="12700">
+            <a:solidFill>
+              <a:srgbClr val="E2E8F0"/>
+            </a:solidFill>
           </a:ln>
           <a:effectLst/>
         </p:spPr>
@@ -8913,58 +9541,14 @@
       </p:sp>
       <p:sp>
         <p:nvSpPr>
-          <p:cNvPr id="6" name="Rectangle 5"/>
+          <p:cNvPr id="9" name="Rectangle 8"/>
           <p:cNvSpPr/>
           <p:nvPr/>
         </p:nvSpPr>
         <p:spPr>
           <a:xfrm>
-            <a:off x="1033271" y="914400"/>
-            <a:ext cx="82296" cy="219456"/>
-          </a:xfrm>
-          <a:prstGeom prst="rect">
-            <a:avLst/>
-          </a:prstGeom>
-          <a:solidFill>
-            <a:srgbClr val="FFFFFF"/>
-          </a:solidFill>
-          <a:ln>
-            <a:noFill/>
-          </a:ln>
-          <a:effectLst/>
-        </p:spPr>
-        <p:style>
-          <a:lnRef idx="1">
-            <a:schemeClr val="accent1"/>
-          </a:lnRef>
-          <a:fillRef idx="3">
-            <a:schemeClr val="accent1"/>
-          </a:fillRef>
-          <a:effectRef idx="2">
-            <a:schemeClr val="accent1"/>
-          </a:effectRef>
-          <a:fontRef idx="minor">
-            <a:schemeClr val="lt1"/>
-          </a:fontRef>
-        </p:style>
-        <p:txBody>
-          <a:bodyPr rtlCol="0" anchor="ctr"/>
-          <a:lstStyle/>
-          <a:p>
-            <a:pPr algn="ctr"/>
-          </a:p>
-        </p:txBody>
-      </p:sp>
-      <p:sp>
-        <p:nvSpPr>
-          <p:cNvPr id="7" name="Rectangle 6"/>
-          <p:cNvSpPr/>
-          <p:nvPr/>
-        </p:nvSpPr>
-        <p:spPr>
-          <a:xfrm>
-            <a:off x="1152143" y="822959"/>
-            <a:ext cx="82296" cy="310896"/>
+            <a:off x="4818888" y="2240279"/>
+            <a:ext cx="457200" cy="109728"/>
           </a:xfrm>
           <a:prstGeom prst="rect">
             <a:avLst/>
@@ -9001,14 +9585,14 @@
       </p:sp>
       <p:sp>
         <p:nvSpPr>
-          <p:cNvPr id="8" name="TextBox 7"/>
+          <p:cNvPr id="10" name="TextBox 9"/>
           <p:cNvSpPr txBox="1"/>
           <p:nvPr/>
         </p:nvSpPr>
         <p:spPr>
           <a:xfrm>
-            <a:off x="1371600" y="768096"/>
-            <a:ext cx="2743200" cy="457200"/>
+            <a:off x="4800600" y="2468880"/>
+            <a:ext cx="2880360" cy="1371599"/>
           </a:xfrm>
           <a:prstGeom prst="rect">
             <a:avLst/>
@@ -9027,84 +9611,91 @@
               </a:spcAft>
             </a:pPr>
             <a:r>
-              <a:rPr sz="2000" b="1" i="0">
-                <a:solidFill>
-                  <a:srgbClr val="FFFFFF"/>
-                </a:solidFill>
-                <a:latin typeface="Calibri"/>
-              </a:rPr>
-              <a:t>Konsilys</a:t>
-            </a:r>
-          </a:p>
-        </p:txBody>
-      </p:sp>
-      <p:sp>
-        <p:nvSpPr>
-          <p:cNvPr id="9" name="TextBox 8"/>
-          <p:cNvSpPr txBox="1"/>
-          <p:nvPr/>
-        </p:nvSpPr>
-        <p:spPr>
-          <a:xfrm>
-            <a:off x="868680" y="2377440"/>
-            <a:ext cx="10424160" cy="1828800"/>
+              <a:rPr sz="1550" b="1" i="0">
+                <a:solidFill>
+                  <a:srgbClr val="1B2B3A"/>
+                </a:solidFill>
+                <a:latin typeface="Calibri"/>
+              </a:rPr>
+              <a:t>Marge consolidée par BU / Practice</a:t>
+            </a:r>
+          </a:p>
+          <a:p>
+            <a:pPr algn="l">
+              <a:spcAft>
+                <a:spcPts val="600"/>
+              </a:spcAft>
+            </a:pPr>
+            <a:r>
+              <a:rPr sz="1200" b="0" i="0">
+                <a:solidFill>
+                  <a:srgbClr val="647485"/>
+                </a:solidFill>
+                <a:latin typeface="Calibri"/>
+              </a:rPr>
+              <a:t>Rentabilité par entité, du groupe jusqu'à l'équipe.</a:t>
+            </a:r>
+          </a:p>
+        </p:txBody>
+      </p:sp>
+      <p:sp>
+        <p:nvSpPr>
+          <p:cNvPr id="11" name="Rounded Rectangle 10"/>
+          <p:cNvSpPr/>
+          <p:nvPr/>
+        </p:nvSpPr>
+        <p:spPr>
+          <a:xfrm>
+            <a:off x="8229600" y="1965960"/>
+            <a:ext cx="3429000" cy="2103120"/>
+          </a:xfrm>
+          <a:prstGeom prst="roundRect">
+            <a:avLst/>
+          </a:prstGeom>
+          <a:solidFill>
+            <a:srgbClr val="F7F9FB"/>
+          </a:solidFill>
+          <a:ln w="12700">
+            <a:solidFill>
+              <a:srgbClr val="E2E8F0"/>
+            </a:solidFill>
+          </a:ln>
+          <a:effectLst/>
+        </p:spPr>
+        <p:style>
+          <a:lnRef idx="1">
+            <a:schemeClr val="accent1"/>
+          </a:lnRef>
+          <a:fillRef idx="3">
+            <a:schemeClr val="accent1"/>
+          </a:fillRef>
+          <a:effectRef idx="2">
+            <a:schemeClr val="accent1"/>
+          </a:effectRef>
+          <a:fontRef idx="minor">
+            <a:schemeClr val="lt1"/>
+          </a:fontRef>
+        </p:style>
+        <p:txBody>
+          <a:bodyPr rtlCol="0" anchor="ctr"/>
+          <a:lstStyle/>
+          <a:p>
+            <a:pPr algn="ctr"/>
+          </a:p>
+        </p:txBody>
+      </p:sp>
+      <p:sp>
+        <p:nvSpPr>
+          <p:cNvPr id="12" name="Rectangle 11"/>
+          <p:cNvSpPr/>
+          <p:nvPr/>
+        </p:nvSpPr>
+        <p:spPr>
+          <a:xfrm>
+            <a:off x="8522208" y="2240279"/>
+            <a:ext cx="457200" cy="109728"/>
           </a:xfrm>
           <a:prstGeom prst="rect">
-            <a:avLst/>
-          </a:prstGeom>
-          <a:noFill/>
-        </p:spPr>
-        <p:txBody>
-          <a:bodyPr wrap="square">
-            <a:spAutoFit/>
-          </a:bodyPr>
-          <a:lstStyle/>
-          <a:p>
-            <a:pPr algn="l">
-              <a:spcAft>
-                <a:spcPts val="1000"/>
-              </a:spcAft>
-            </a:pPr>
-            <a:r>
-              <a:rPr sz="3800" b="1" i="0">
-                <a:solidFill>
-                  <a:srgbClr val="FFFFFF"/>
-                </a:solidFill>
-                <a:latin typeface="Calibri"/>
-              </a:rPr>
-              <a:t>Prêt à piloter votre ESN autrement ?</a:t>
-            </a:r>
-          </a:p>
-          <a:p>
-            <a:pPr algn="l">
-              <a:spcAft>
-                <a:spcPts val="600"/>
-              </a:spcAft>
-            </a:pPr>
-            <a:r>
-              <a:rPr sz="1800" b="0" i="0">
-                <a:solidFill>
-                  <a:srgbClr val="C7D2DD"/>
-                </a:solidFill>
-                <a:latin typeface="Calibri"/>
-              </a:rPr>
-              <a:t>Souscrivez en ligne dès aujourd'hui, ou demandez une démonstration personnalisée avec vos propres données.</a:t>
-            </a:r>
-          </a:p>
-        </p:txBody>
-      </p:sp>
-      <p:sp>
-        <p:nvSpPr>
-          <p:cNvPr id="10" name="Rounded Rectangle 9"/>
-          <p:cNvSpPr/>
-          <p:nvPr/>
-        </p:nvSpPr>
-        <p:spPr>
-          <a:xfrm>
-            <a:off x="868680" y="4480560"/>
-            <a:ext cx="3017520" cy="777240"/>
-          </a:xfrm>
-          <a:prstGeom prst="roundRect">
             <a:avLst/>
           </a:prstGeom>
           <a:solidFill>
@@ -9133,33 +9724,20 @@
           <a:bodyPr rtlCol="0" anchor="ctr"/>
           <a:lstStyle/>
           <a:p>
-            <a:pPr algn="ctr">
-              <a:spcAft>
-                <a:spcPts val="600"/>
-              </a:spcAft>
-            </a:pPr>
-            <a:r>
-              <a:rPr sz="1800" b="1" i="0">
-                <a:solidFill>
-                  <a:srgbClr val="1B2B3A"/>
-                </a:solidFill>
-                <a:latin typeface="Calibri"/>
-              </a:rPr>
-              <a:t>konsilys.fr</a:t>
-            </a:r>
-          </a:p>
-        </p:txBody>
-      </p:sp>
-      <p:sp>
-        <p:nvSpPr>
-          <p:cNvPr id="11" name="TextBox 10"/>
+            <a:pPr algn="ctr"/>
+          </a:p>
+        </p:txBody>
+      </p:sp>
+      <p:sp>
+        <p:nvSpPr>
+          <p:cNvPr id="13" name="TextBox 12"/>
           <p:cNvSpPr txBox="1"/>
           <p:nvPr/>
         </p:nvSpPr>
         <p:spPr>
           <a:xfrm>
-            <a:off x="4206240" y="4617720"/>
-            <a:ext cx="6400800" cy="640080"/>
+            <a:off x="8503920" y="2468880"/>
+            <a:ext cx="2880360" cy="1371599"/>
           </a:xfrm>
           <a:prstGeom prst="rect">
             <a:avLst/>
@@ -9178,13 +9756,503 @@
               </a:spcAft>
             </a:pPr>
             <a:r>
-              <a:rPr sz="1800" b="1" i="0">
-                <a:solidFill>
-                  <a:srgbClr val="FFFFFF"/>
-                </a:solidFill>
-                <a:latin typeface="Calibri"/>
-              </a:rPr>
-              <a:t>contact@konsilys.fr</a:t>
+              <a:rPr sz="1550" b="1" i="0">
+                <a:solidFill>
+                  <a:srgbClr val="1B2B3A"/>
+                </a:solidFill>
+                <a:latin typeface="Calibri"/>
+              </a:rPr>
+              <a:t>Hiérarchie multi-BU (6 niveaux)</a:t>
+            </a:r>
+          </a:p>
+          <a:p>
+            <a:pPr algn="l">
+              <a:spcAft>
+                <a:spcPts val="600"/>
+              </a:spcAft>
+            </a:pPr>
+            <a:r>
+              <a:rPr sz="1200" b="0" i="0">
+                <a:solidFill>
+                  <a:srgbClr val="647485"/>
+                </a:solidFill>
+                <a:latin typeface="Calibri"/>
+              </a:rPr>
+              <a:t>Monde › région › agence › équipe. Un nouveau compte hérite de la BU de son créateur.</a:t>
+            </a:r>
+          </a:p>
+        </p:txBody>
+      </p:sp>
+      <p:sp>
+        <p:nvSpPr>
+          <p:cNvPr id="14" name="Rounded Rectangle 13"/>
+          <p:cNvSpPr/>
+          <p:nvPr/>
+        </p:nvSpPr>
+        <p:spPr>
+          <a:xfrm>
+            <a:off x="822960" y="4343400"/>
+            <a:ext cx="3429000" cy="2103120"/>
+          </a:xfrm>
+          <a:prstGeom prst="roundRect">
+            <a:avLst/>
+          </a:prstGeom>
+          <a:solidFill>
+            <a:srgbClr val="F7F9FB"/>
+          </a:solidFill>
+          <a:ln w="12700">
+            <a:solidFill>
+              <a:srgbClr val="E2E8F0"/>
+            </a:solidFill>
+          </a:ln>
+          <a:effectLst/>
+        </p:spPr>
+        <p:style>
+          <a:lnRef idx="1">
+            <a:schemeClr val="accent1"/>
+          </a:lnRef>
+          <a:fillRef idx="3">
+            <a:schemeClr val="accent1"/>
+          </a:fillRef>
+          <a:effectRef idx="2">
+            <a:schemeClr val="accent1"/>
+          </a:effectRef>
+          <a:fontRef idx="minor">
+            <a:schemeClr val="lt1"/>
+          </a:fontRef>
+        </p:style>
+        <p:txBody>
+          <a:bodyPr rtlCol="0" anchor="ctr"/>
+          <a:lstStyle/>
+          <a:p>
+            <a:pPr algn="ctr"/>
+          </a:p>
+        </p:txBody>
+      </p:sp>
+      <p:sp>
+        <p:nvSpPr>
+          <p:cNvPr id="15" name="Rectangle 14"/>
+          <p:cNvSpPr/>
+          <p:nvPr/>
+        </p:nvSpPr>
+        <p:spPr>
+          <a:xfrm>
+            <a:off x="1115568" y="4617720"/>
+            <a:ext cx="457200" cy="109728"/>
+          </a:xfrm>
+          <a:prstGeom prst="rect">
+            <a:avLst/>
+          </a:prstGeom>
+          <a:solidFill>
+            <a:srgbClr val="84CC16"/>
+          </a:solidFill>
+          <a:ln>
+            <a:noFill/>
+          </a:ln>
+          <a:effectLst/>
+        </p:spPr>
+        <p:style>
+          <a:lnRef idx="1">
+            <a:schemeClr val="accent1"/>
+          </a:lnRef>
+          <a:fillRef idx="3">
+            <a:schemeClr val="accent1"/>
+          </a:fillRef>
+          <a:effectRef idx="2">
+            <a:schemeClr val="accent1"/>
+          </a:effectRef>
+          <a:fontRef idx="minor">
+            <a:schemeClr val="lt1"/>
+          </a:fontRef>
+        </p:style>
+        <p:txBody>
+          <a:bodyPr rtlCol="0" anchor="ctr"/>
+          <a:lstStyle/>
+          <a:p>
+            <a:pPr algn="ctr"/>
+          </a:p>
+        </p:txBody>
+      </p:sp>
+      <p:sp>
+        <p:nvSpPr>
+          <p:cNvPr id="16" name="TextBox 15"/>
+          <p:cNvSpPr txBox="1"/>
+          <p:nvPr/>
+        </p:nvSpPr>
+        <p:spPr>
+          <a:xfrm>
+            <a:off x="1097280" y="4846320"/>
+            <a:ext cx="2880360" cy="1371599"/>
+          </a:xfrm>
+          <a:prstGeom prst="rect">
+            <a:avLst/>
+          </a:prstGeom>
+          <a:noFill/>
+        </p:spPr>
+        <p:txBody>
+          <a:bodyPr wrap="square">
+            <a:spAutoFit/>
+          </a:bodyPr>
+          <a:lstStyle/>
+          <a:p>
+            <a:pPr algn="l">
+              <a:spcAft>
+                <a:spcPts val="600"/>
+              </a:spcAft>
+            </a:pPr>
+            <a:r>
+              <a:rPr sz="1550" b="1" i="0">
+                <a:solidFill>
+                  <a:srgbClr val="1B2B3A"/>
+                </a:solidFill>
+                <a:latin typeface="Calibri"/>
+              </a:rPr>
+              <a:t>Recrutement intelligent</a:t>
+            </a:r>
+          </a:p>
+          <a:p>
+            <a:pPr algn="l">
+              <a:spcAft>
+                <a:spcPts val="600"/>
+              </a:spcAft>
+            </a:pPr>
+            <a:r>
+              <a:rPr sz="1200" b="0" i="0">
+                <a:solidFill>
+                  <a:srgbClr val="647485"/>
+                </a:solidFill>
+                <a:latin typeface="Calibri"/>
+              </a:rPr>
+              <a:t>Pipeline partagé + matching expertise / localisation / expérience / secteur ; localisation cible, secondaire et mobilité.</a:t>
+            </a:r>
+          </a:p>
+        </p:txBody>
+      </p:sp>
+      <p:sp>
+        <p:nvSpPr>
+          <p:cNvPr id="17" name="Rounded Rectangle 16"/>
+          <p:cNvSpPr/>
+          <p:nvPr/>
+        </p:nvSpPr>
+        <p:spPr>
+          <a:xfrm>
+            <a:off x="4526280" y="4343400"/>
+            <a:ext cx="3429000" cy="2103120"/>
+          </a:xfrm>
+          <a:prstGeom prst="roundRect">
+            <a:avLst/>
+          </a:prstGeom>
+          <a:solidFill>
+            <a:srgbClr val="F7F9FB"/>
+          </a:solidFill>
+          <a:ln w="12700">
+            <a:solidFill>
+              <a:srgbClr val="E2E8F0"/>
+            </a:solidFill>
+          </a:ln>
+          <a:effectLst/>
+        </p:spPr>
+        <p:style>
+          <a:lnRef idx="1">
+            <a:schemeClr val="accent1"/>
+          </a:lnRef>
+          <a:fillRef idx="3">
+            <a:schemeClr val="accent1"/>
+          </a:fillRef>
+          <a:effectRef idx="2">
+            <a:schemeClr val="accent1"/>
+          </a:effectRef>
+          <a:fontRef idx="minor">
+            <a:schemeClr val="lt1"/>
+          </a:fontRef>
+        </p:style>
+        <p:txBody>
+          <a:bodyPr rtlCol="0" anchor="ctr"/>
+          <a:lstStyle/>
+          <a:p>
+            <a:pPr algn="ctr"/>
+          </a:p>
+        </p:txBody>
+      </p:sp>
+      <p:sp>
+        <p:nvSpPr>
+          <p:cNvPr id="18" name="Rectangle 17"/>
+          <p:cNvSpPr/>
+          <p:nvPr/>
+        </p:nvSpPr>
+        <p:spPr>
+          <a:xfrm>
+            <a:off x="4818888" y="4617720"/>
+            <a:ext cx="457200" cy="109728"/>
+          </a:xfrm>
+          <a:prstGeom prst="rect">
+            <a:avLst/>
+          </a:prstGeom>
+          <a:solidFill>
+            <a:srgbClr val="84CC16"/>
+          </a:solidFill>
+          <a:ln>
+            <a:noFill/>
+          </a:ln>
+          <a:effectLst/>
+        </p:spPr>
+        <p:style>
+          <a:lnRef idx="1">
+            <a:schemeClr val="accent1"/>
+          </a:lnRef>
+          <a:fillRef idx="3">
+            <a:schemeClr val="accent1"/>
+          </a:fillRef>
+          <a:effectRef idx="2">
+            <a:schemeClr val="accent1"/>
+          </a:effectRef>
+          <a:fontRef idx="minor">
+            <a:schemeClr val="lt1"/>
+          </a:fontRef>
+        </p:style>
+        <p:txBody>
+          <a:bodyPr rtlCol="0" anchor="ctr"/>
+          <a:lstStyle/>
+          <a:p>
+            <a:pPr algn="ctr"/>
+          </a:p>
+        </p:txBody>
+      </p:sp>
+      <p:sp>
+        <p:nvSpPr>
+          <p:cNvPr id="19" name="TextBox 18"/>
+          <p:cNvSpPr txBox="1"/>
+          <p:nvPr/>
+        </p:nvSpPr>
+        <p:spPr>
+          <a:xfrm>
+            <a:off x="4800600" y="4846320"/>
+            <a:ext cx="2880360" cy="1371599"/>
+          </a:xfrm>
+          <a:prstGeom prst="rect">
+            <a:avLst/>
+          </a:prstGeom>
+          <a:noFill/>
+        </p:spPr>
+        <p:txBody>
+          <a:bodyPr wrap="square">
+            <a:spAutoFit/>
+          </a:bodyPr>
+          <a:lstStyle/>
+          <a:p>
+            <a:pPr algn="l">
+              <a:spcAft>
+                <a:spcPts val="600"/>
+              </a:spcAft>
+            </a:pPr>
+            <a:r>
+              <a:rPr sz="1550" b="1" i="0">
+                <a:solidFill>
+                  <a:srgbClr val="1B2B3A"/>
+                </a:solidFill>
+                <a:latin typeface="Calibri"/>
+              </a:rPr>
+              <a:t>Sécurité de niveau entreprise</a:t>
+            </a:r>
+          </a:p>
+          <a:p>
+            <a:pPr algn="l">
+              <a:spcAft>
+                <a:spcPts val="600"/>
+              </a:spcAft>
+            </a:pPr>
+            <a:r>
+              <a:rPr sz="1200" b="0" i="0">
+                <a:solidFill>
+                  <a:srgbClr val="647485"/>
+                </a:solidFill>
+                <a:latin typeface="Calibri"/>
+              </a:rPr>
+              <a:t>Isolation RLS auditée, journal d'audit horodaté, permissions fines — conformité RGPD.</a:t>
+            </a:r>
+          </a:p>
+        </p:txBody>
+      </p:sp>
+      <p:sp>
+        <p:nvSpPr>
+          <p:cNvPr id="20" name="Rounded Rectangle 19"/>
+          <p:cNvSpPr/>
+          <p:nvPr/>
+        </p:nvSpPr>
+        <p:spPr>
+          <a:xfrm>
+            <a:off x="8229600" y="4343400"/>
+            <a:ext cx="3429000" cy="2103120"/>
+          </a:xfrm>
+          <a:prstGeom prst="roundRect">
+            <a:avLst/>
+          </a:prstGeom>
+          <a:solidFill>
+            <a:srgbClr val="F7F9FB"/>
+          </a:solidFill>
+          <a:ln w="12700">
+            <a:solidFill>
+              <a:srgbClr val="E2E8F0"/>
+            </a:solidFill>
+          </a:ln>
+          <a:effectLst/>
+        </p:spPr>
+        <p:style>
+          <a:lnRef idx="1">
+            <a:schemeClr val="accent1"/>
+          </a:lnRef>
+          <a:fillRef idx="3">
+            <a:schemeClr val="accent1"/>
+          </a:fillRef>
+          <a:effectRef idx="2">
+            <a:schemeClr val="accent1"/>
+          </a:effectRef>
+          <a:fontRef idx="minor">
+            <a:schemeClr val="lt1"/>
+          </a:fontRef>
+        </p:style>
+        <p:txBody>
+          <a:bodyPr rtlCol="0" anchor="ctr"/>
+          <a:lstStyle/>
+          <a:p>
+            <a:pPr algn="ctr"/>
+          </a:p>
+        </p:txBody>
+      </p:sp>
+      <p:sp>
+        <p:nvSpPr>
+          <p:cNvPr id="21" name="Rectangle 20"/>
+          <p:cNvSpPr/>
+          <p:nvPr/>
+        </p:nvSpPr>
+        <p:spPr>
+          <a:xfrm>
+            <a:off x="8522208" y="4617720"/>
+            <a:ext cx="457200" cy="109728"/>
+          </a:xfrm>
+          <a:prstGeom prst="rect">
+            <a:avLst/>
+          </a:prstGeom>
+          <a:solidFill>
+            <a:srgbClr val="84CC16"/>
+          </a:solidFill>
+          <a:ln>
+            <a:noFill/>
+          </a:ln>
+          <a:effectLst/>
+        </p:spPr>
+        <p:style>
+          <a:lnRef idx="1">
+            <a:schemeClr val="accent1"/>
+          </a:lnRef>
+          <a:fillRef idx="3">
+            <a:schemeClr val="accent1"/>
+          </a:fillRef>
+          <a:effectRef idx="2">
+            <a:schemeClr val="accent1"/>
+          </a:effectRef>
+          <a:fontRef idx="minor">
+            <a:schemeClr val="lt1"/>
+          </a:fontRef>
+        </p:style>
+        <p:txBody>
+          <a:bodyPr rtlCol="0" anchor="ctr"/>
+          <a:lstStyle/>
+          <a:p>
+            <a:pPr algn="ctr"/>
+          </a:p>
+        </p:txBody>
+      </p:sp>
+      <p:sp>
+        <p:nvSpPr>
+          <p:cNvPr id="22" name="TextBox 21"/>
+          <p:cNvSpPr txBox="1"/>
+          <p:nvPr/>
+        </p:nvSpPr>
+        <p:spPr>
+          <a:xfrm>
+            <a:off x="8503920" y="4846320"/>
+            <a:ext cx="2880360" cy="1371599"/>
+          </a:xfrm>
+          <a:prstGeom prst="rect">
+            <a:avLst/>
+          </a:prstGeom>
+          <a:noFill/>
+        </p:spPr>
+        <p:txBody>
+          <a:bodyPr wrap="square">
+            <a:spAutoFit/>
+          </a:bodyPr>
+          <a:lstStyle/>
+          <a:p>
+            <a:pPr algn="l">
+              <a:spcAft>
+                <a:spcPts val="600"/>
+              </a:spcAft>
+            </a:pPr>
+            <a:r>
+              <a:rPr sz="1550" b="1" i="0">
+                <a:solidFill>
+                  <a:srgbClr val="1B2B3A"/>
+                </a:solidFill>
+                <a:latin typeface="Calibri"/>
+              </a:rPr>
+              <a:t>Robustesse</a:t>
+            </a:r>
+          </a:p>
+          <a:p>
+            <a:pPr algn="l">
+              <a:spcAft>
+                <a:spcPts val="600"/>
+              </a:spcAft>
+            </a:pPr>
+            <a:r>
+              <a:rPr sz="1200" b="0" i="0">
+                <a:solidFill>
+                  <a:srgbClr val="647485"/>
+                </a:solidFill>
+                <a:latin typeface="Calibri"/>
+              </a:rPr>
+              <a:t>Base de code modulaire et tests automatisés de non-régression.</a:t>
+            </a:r>
+          </a:p>
+        </p:txBody>
+      </p:sp>
+      <p:sp>
+        <p:nvSpPr>
+          <p:cNvPr id="23" name="TextBox 22"/>
+          <p:cNvSpPr txBox="1"/>
+          <p:nvPr/>
+        </p:nvSpPr>
+        <p:spPr>
+          <a:xfrm>
+            <a:off x="11247120" y="6419088"/>
+            <a:ext cx="822960" cy="365760"/>
+          </a:xfrm>
+          <a:prstGeom prst="rect">
+            <a:avLst/>
+          </a:prstGeom>
+          <a:noFill/>
+        </p:spPr>
+        <p:txBody>
+          <a:bodyPr wrap="square">
+            <a:spAutoFit/>
+          </a:bodyPr>
+          <a:lstStyle/>
+          <a:p>
+            <a:pPr algn="r">
+              <a:spcAft>
+                <a:spcPts val="600"/>
+              </a:spcAft>
+            </a:pPr>
+            <a:r>
+              <a:rPr sz="1000" b="0" i="0">
+                <a:solidFill>
+                  <a:srgbClr val="647485"/>
+                </a:solidFill>
+                <a:latin typeface="Calibri"/>
+              </a:rPr>
+              <a:t>9</a:t>
             </a:r>
           </a:p>
         </p:txBody>

</xml_diff>